<commit_message>
Fix name: Manh -> Marc Bui
Co-Authored-By: Claude Opus 4.6 <noreply@anthropic.com>
</commit_message>
<xml_diff>
--- a/Behavioral_Baseline_Deck.pptx
+++ b/Behavioral_Baseline_Deck.pptx
@@ -3248,7 +3248,7 @@
                 </a:solidFill>
                 <a:latin typeface="Calibri"/>
               </a:rPr>
-              <a:t>Manh Bui  |  Splunk</a:t>
+              <a:t>Marc Bui  |  Splunk</a:t>
             </a:r>
           </a:p>
         </p:txBody>
@@ -4180,7 +4180,7 @@
                 </a:solidFill>
                 <a:latin typeface="Calibri"/>
               </a:rPr>
-              <a:t>Questions?  —  Manh Bui  |  Splunk Observability</a:t>
+              <a:t>Questions?  —  Marc Bui  |  Splunk Observability</a:t>
             </a:r>
           </a:p>
         </p:txBody>

</xml_diff>

<commit_message>
Rename to Behavioral Anomaly Detection Framework throughout deck
Co-Authored-By: Claude Opus 4.6 <noreply@anthropic.com>
</commit_message>
<xml_diff>
--- a/Behavioral_Baseline_Deck.pptx
+++ b/Behavioral_Baseline_Deck.pptx
@@ -3178,7 +3178,7 @@
                 </a:solidFill>
                 <a:latin typeface="Calibri"/>
               </a:rPr>
-              <a:t>Behavioral Baseline</a:t>
+              <a:t>Behavioral Anomaly Detection Framework</a:t>
             </a:r>
           </a:p>
         </p:txBody>
@@ -3213,7 +3213,7 @@
                 </a:solidFill>
                 <a:latin typeface="Calibri"/>
               </a:rPr>
-              <a:t>AI-Powered Anomaly Detection for Splunk Observability APM</a:t>
+              <a:t>AI-Powered Behavioral Anomaly Detection for Splunk Observability APM</a:t>
             </a:r>
           </a:p>
         </p:txBody>
@@ -6355,7 +6355,7 @@
                 </a:solidFill>
                 <a:latin typeface="Calibri"/>
               </a:rPr>
-              <a:t>What Behavioral Baseline Does</a:t>
+              <a:t>What the Behavioral Anomaly Detection Framework Does</a:t>
             </a:r>
           </a:p>
         </p:txBody>
@@ -8328,7 +8328,7 @@
                 </a:solidFill>
                 <a:latin typeface="Calibri"/>
               </a:rPr>
-              <a:t>Behavioral Baseline adds on top</a:t>
+              <a:t>Behavioral Anomaly Detection adds on top</a:t>
             </a:r>
           </a:p>
         </p:txBody>

</xml_diff>

<commit_message>
Center title slide text
Co-Authored-By: Claude Opus 4.6 <noreply@anthropic.com>
</commit_message>
<xml_diff>
--- a/Behavioral_Baseline_Deck.pptx
+++ b/Behavioral_Baseline_Deck.pptx
@@ -3157,20 +3157,20 @@
         <p:spPr>
           <a:xfrm>
             <a:off x="411480" y="1280160"/>
-            <a:ext cx="5943600" cy="1280160"/>
-          </a:xfrm>
-          <a:prstGeom prst="rect">
-            <a:avLst/>
-          </a:prstGeom>
-          <a:noFill/>
-        </p:spPr>
-        <p:txBody>
-          <a:bodyPr wrap="square">
-            <a:spAutoFit/>
-          </a:bodyPr>
-          <a:lstStyle/>
-          <a:p>
-            <a:pPr algn="l"/>
+            <a:ext cx="8412480" cy="1280160"/>
+          </a:xfrm>
+          <a:prstGeom prst="rect">
+            <a:avLst/>
+          </a:prstGeom>
+          <a:noFill/>
+        </p:spPr>
+        <p:txBody>
+          <a:bodyPr wrap="square">
+            <a:spAutoFit/>
+          </a:bodyPr>
+          <a:lstStyle/>
+          <a:p>
+            <a:pPr algn="ctr"/>
             <a:r>
               <a:rPr sz="4400" b="1">
                 <a:solidFill>
@@ -3192,20 +3192,20 @@
         <p:spPr>
           <a:xfrm>
             <a:off x="411480" y="2514600"/>
-            <a:ext cx="5943600" cy="548640"/>
-          </a:xfrm>
-          <a:prstGeom prst="rect">
-            <a:avLst/>
-          </a:prstGeom>
-          <a:noFill/>
-        </p:spPr>
-        <p:txBody>
-          <a:bodyPr wrap="square">
-            <a:spAutoFit/>
-          </a:bodyPr>
-          <a:lstStyle/>
-          <a:p>
-            <a:pPr algn="l"/>
+            <a:ext cx="8412480" cy="548640"/>
+          </a:xfrm>
+          <a:prstGeom prst="rect">
+            <a:avLst/>
+          </a:prstGeom>
+          <a:noFill/>
+        </p:spPr>
+        <p:txBody>
+          <a:bodyPr wrap="square">
+            <a:spAutoFit/>
+          </a:bodyPr>
+          <a:lstStyle/>
+          <a:p>
+            <a:pPr algn="ctr"/>
             <a:r>
               <a:rPr sz="1800" b="0">
                 <a:solidFill>
@@ -3227,20 +3227,20 @@
         <p:spPr>
           <a:xfrm>
             <a:off x="411480" y="3200400"/>
-            <a:ext cx="3657600" cy="365760"/>
-          </a:xfrm>
-          <a:prstGeom prst="rect">
-            <a:avLst/>
-          </a:prstGeom>
-          <a:noFill/>
-        </p:spPr>
-        <p:txBody>
-          <a:bodyPr wrap="square">
-            <a:spAutoFit/>
-          </a:bodyPr>
-          <a:lstStyle/>
-          <a:p>
-            <a:pPr algn="l"/>
+            <a:ext cx="8412480" cy="365760"/>
+          </a:xfrm>
+          <a:prstGeom prst="rect">
+            <a:avLst/>
+          </a:prstGeom>
+          <a:noFill/>
+        </p:spPr>
+        <p:txBody>
+          <a:bodyPr wrap="square">
+            <a:spAutoFit/>
+          </a:bodyPr>
+          <a:lstStyle/>
+          <a:p>
+            <a:pPr algn="ctr"/>
             <a:r>
               <a:rPr sz="1300" b="0">
                 <a:solidFill>

</xml_diff>

<commit_message>
Update slides: Demo 4 title + tier model to reflect MULTI_TIER
- Demo agenda: Demo 4 renamed to "All-Tier Correlation", description
  updated to mention AutoDetect + MULTI_TIER / Critical
- Tiers slide: Correlation box now shows all 4 correlation types
  (TIER2_TIER3 Major, TIER1_TIER2/TIER1_TIER3 Major, MULTI_TIER Critical)
- Tiers slide: bottom callout updated to show all 3 tiers + [Critical] MULTI_TIER
- Architecture slide: "Joins Tier 1 + 2 + 3" (was Tier 2 + Tier 3)
- AutoDetect relationship slide: "Tier 1 + 2 + 3" correlation bullet
- Solution overview: clarified correlated alert escalates to MULTI_TIER

Co-Authored-By: Claude Opus 4.6 <noreply@anthropic.com>
</commit_message>
<xml_diff>
--- a/Behavioral_Baseline_Deck.pptx
+++ b/Behavioral_Baseline_Deck.pptx
@@ -6133,12 +6133,13 @@
                 </a:solidFill>
                 <a:latin typeface="Calibri"/>
               </a:rPr>
-              <a:t>TIER2_TIER3
-  → trace + error both fired
-     on same service
-     = high-confidence incident
-Downgrades if a recent
-deployment event matches</a:t>
+              <a:t>TIER2_TIER3  → Major
+  trace + error on same service
+TIER1_TIER2 / TIER1_TIER3
+  → Major
+MULTI_TIER  → Critical
+  all 3 tiers on same service
+  = highest confidence</a:t>
             </a:r>
           </a:p>
         </p:txBody>
@@ -6216,7 +6217,7 @@
                 </a:solidFill>
                 <a:latin typeface="Calibri"/>
               </a:rPr>
-              <a:t>Demo 4:  vets-service + DB down  →  Tier 2 fires MISSING_SERVICE  +  Tier 3 fires NEW_ERROR_SIGNATURE  →  correlate.py emits  [Major] TIER2_TIER3  on customers-service</a:t>
+              <a:t>Demo 4:  vets-service + DB down  →  Tier 1 (AutoDetect error rate)  +  Tier 2 (MISSING_SERVICE)  +  Tier 3 (NEW_ERROR_SIGNATURE)  →  correlate.py emits  [Critical] MULTI_TIER</a:t>
             </a:r>
           </a:p>
         </p:txBody>
@@ -6817,7 +6818,7 @@
                 </a:solidFill>
                 <a:latin typeface="Calibri"/>
               </a:rPr>
-              <a:t>  •  2+ tiers on same service → correlated alert</a:t>
+              <a:t>  •  2+ tiers on same service → correlated alert (up to [Critical] MULTI_TIER)</a:t>
             </a:r>
           </a:p>
           <a:p>
@@ -7572,8 +7573,9 @@
                 </a:solidFill>
                 <a:latin typeface="Calibri"/>
               </a:rPr>
-              <a:t>Joins Tier 2 + Tier 3
+              <a:t>Joins Tier 1 + 2 + 3
 events by service
+MULTI_TIER = Critical
 Annotates with
 deployment context
 Downgrades severity
@@ -8399,7 +8401,7 @@
                 </a:solidFill>
                 <a:latin typeface="Calibri"/>
               </a:rPr>
-              <a:t>  •  Cross-tier correlation (Tier 2 + 3)</a:t>
+              <a:t>  •  Cross-tier correlation (Tier 1 + 2 + 3)</a:t>
             </a:r>
           </a:p>
           <a:p>
@@ -10378,7 +10380,7 @@
                 </a:solidFill>
                 <a:latin typeface="Calibri"/>
               </a:rPr>
-              <a:t>Dual-Tier Correlation</a:t>
+              <a:t>All-Tier Correlation</a:t>
             </a:r>
           </a:p>
         </p:txBody>
@@ -10413,7 +10415,7 @@
                 </a:solidFill>
                 <a:latin typeface="Calibri"/>
               </a:rPr>
-              <a:t>Both vets-service and DB down simultaneously. 9 individual signals collapsed into 1 TIER2_TIER3 correlated alert</a:t>
+              <a:t>Both vets-service and DB down simultaneously. AutoDetect + trace drift + error signatures → [Critical] MULTI_TIER</a:t>
             </a:r>
           </a:p>
         </p:txBody>

</xml_diff>

<commit_message>
Update slide 10 and talk track for PM productization pitch
- Slide 10: reframed from "next steps" to "Product Proposal: Make This Native"
  with three pillars: Native Platform Integration, AI Triage as Product Feature,
  Platform Differentiation
- TALK_TRACK.md: updated slide 10 talk track to pitch productization into
  Splunk Observability Cloud platform
</commit_message>
<xml_diff>
--- a/Behavioral_Baseline_Deck.pptx
+++ b/Behavioral_Baseline_Deck.pptx
@@ -3381,13 +3381,13 @@
           <a:p>
             <a:pPr algn="l"/>
             <a:r>
-              <a:rPr sz="2600" b="1">
+              <a:rPr sz="2200" b="1">
                 <a:solidFill>
                   <a:srgbClr val="00BCEB"/>
                 </a:solidFill>
                 <a:latin typeface="Calibri"/>
               </a:rPr>
-              <a:t>Next Steps</a:t>
+              <a:t>Product Proposal: Make This Native to Splunk Observability Cloud</a:t>
             </a:r>
           </a:p>
         </p:txBody>
@@ -3437,14 +3437,49 @@
       </p:sp>
       <p:sp>
         <p:nvSpPr>
-          <p:cNvPr id="5" name="Rectangle 4"/>
+          <p:cNvPr id="5" name="TextBox 4"/>
+          <p:cNvSpPr txBox="1"/>
+          <p:nvPr/>
+        </p:nvSpPr>
+        <p:spPr>
+          <a:xfrm>
+            <a:off x="411480" y="896112"/>
+            <a:ext cx="8412480" cy="347472"/>
+          </a:xfrm>
+          <a:prstGeom prst="rect">
+            <a:avLst/>
+          </a:prstGeom>
+          <a:noFill/>
+        </p:spPr>
+        <p:txBody>
+          <a:bodyPr wrap="square">
+            <a:spAutoFit/>
+          </a:bodyPr>
+          <a:lstStyle/>
+          <a:p>
+            <a:pPr algn="l"/>
+            <a:r>
+              <a:rPr sz="1200" b="0">
+                <a:solidFill>
+                  <a:srgbClr val="CCDDEE"/>
+                </a:solidFill>
+                <a:latin typeface="Calibri"/>
+              </a:rPr>
+              <a:t>The proof of concept is working in production today. The ask: productize this as a native platform capability.</a:t>
+            </a:r>
+          </a:p>
+        </p:txBody>
+      </p:sp>
+      <p:sp>
+        <p:nvSpPr>
+          <p:cNvPr id="6" name="Rectangle 5"/>
           <p:cNvSpPr/>
           <p:nvPr/>
         </p:nvSpPr>
         <p:spPr>
           <a:xfrm>
-            <a:off x="411480" y="960120"/>
-            <a:ext cx="2651760" cy="3291840"/>
+            <a:off x="411480" y="1325880"/>
+            <a:ext cx="2651760" cy="3154680"/>
           </a:xfrm>
           <a:prstGeom prst="rect">
             <a:avLst/>
@@ -3480,13 +3515,13 @@
       </p:sp>
       <p:sp>
         <p:nvSpPr>
-          <p:cNvPr id="6" name="Rectangle 5"/>
+          <p:cNvPr id="7" name="Rectangle 6"/>
           <p:cNvSpPr/>
           <p:nvPr/>
         </p:nvSpPr>
         <p:spPr>
           <a:xfrm>
-            <a:off x="411480" y="960120"/>
+            <a:off x="411480" y="1325880"/>
             <a:ext cx="2651760" cy="54864"/>
           </a:xfrm>
           <a:prstGeom prst="rect">
@@ -3523,13 +3558,13 @@
       </p:sp>
       <p:sp>
         <p:nvSpPr>
-          <p:cNvPr id="7" name="Rectangle 6"/>
+          <p:cNvPr id="8" name="Rectangle 7"/>
           <p:cNvSpPr/>
           <p:nvPr/>
         </p:nvSpPr>
         <p:spPr>
           <a:xfrm>
-            <a:off x="521208" y="1069848"/>
+            <a:off x="521208" y="1417320"/>
             <a:ext cx="292608" cy="292608"/>
           </a:xfrm>
           <a:prstGeom prst="rect">
@@ -3566,13 +3601,13 @@
       </p:sp>
       <p:sp>
         <p:nvSpPr>
-          <p:cNvPr id="8" name="TextBox 7"/>
-          <p:cNvSpPr txBox="1"/>
-          <p:nvPr/>
-        </p:nvSpPr>
-        <p:spPr>
-          <a:xfrm>
-            <a:off x="521208" y="1051560"/>
+          <p:cNvPr id="9" name="TextBox 8"/>
+          <p:cNvSpPr txBox="1"/>
+          <p:nvPr/>
+        </p:nvSpPr>
+        <p:spPr>
+          <a:xfrm>
+            <a:off x="521208" y="1399032"/>
             <a:ext cx="292608" cy="320040"/>
           </a:xfrm>
           <a:prstGeom prst="rect">
@@ -3601,13 +3636,13 @@
       </p:sp>
       <p:sp>
         <p:nvSpPr>
-          <p:cNvPr id="9" name="TextBox 8"/>
-          <p:cNvSpPr txBox="1"/>
-          <p:nvPr/>
-        </p:nvSpPr>
-        <p:spPr>
-          <a:xfrm>
-            <a:off x="886968" y="1051560"/>
+          <p:cNvPr id="10" name="TextBox 9"/>
+          <p:cNvSpPr txBox="1"/>
+          <p:nvPr/>
+        </p:nvSpPr>
+        <p:spPr>
+          <a:xfrm>
+            <a:off x="886968" y="1399032"/>
             <a:ext cx="2057400" cy="384048"/>
           </a:xfrm>
           <a:prstGeom prst="rect">
@@ -3629,59 +3664,63 @@
                 </a:solidFill>
                 <a:latin typeface="Calibri"/>
               </a:rPr>
-              <a:t>Pilot Environment</a:t>
-            </a:r>
-          </a:p>
-        </p:txBody>
-      </p:sp>
-      <p:sp>
-        <p:nvSpPr>
-          <p:cNvPr id="10" name="TextBox 9"/>
-          <p:cNvSpPr txBox="1"/>
-          <p:nvPr/>
-        </p:nvSpPr>
-        <p:spPr>
-          <a:xfrm>
-            <a:off x="521208" y="1508760"/>
-            <a:ext cx="2450592" cy="2651760"/>
-          </a:xfrm>
-          <a:prstGeom prst="rect">
-            <a:avLst/>
-          </a:prstGeom>
-          <a:noFill/>
-        </p:spPr>
-        <p:txBody>
-          <a:bodyPr wrap="square">
-            <a:spAutoFit/>
-          </a:bodyPr>
-          <a:lstStyle/>
-          <a:p>
-            <a:pPr algn="l"/>
-            <a:r>
-              <a:rPr sz="1100" b="0">
+              <a:t>Native Platform Integration</a:t>
+            </a:r>
+          </a:p>
+        </p:txBody>
+      </p:sp>
+      <p:sp>
+        <p:nvSpPr>
+          <p:cNvPr id="11" name="TextBox 10"/>
+          <p:cNvSpPr txBox="1"/>
+          <p:nvPr/>
+        </p:nvSpPr>
+        <p:spPr>
+          <a:xfrm>
+            <a:off x="521208" y="1856232"/>
+            <a:ext cx="2450592" cy="2514600"/>
+          </a:xfrm>
+          <a:prstGeom prst="rect">
+            <a:avLst/>
+          </a:prstGeom>
+          <a:noFill/>
+        </p:spPr>
+        <p:txBody>
+          <a:bodyPr wrap="square">
+            <a:spAutoFit/>
+          </a:bodyPr>
+          <a:lstStyle/>
+          <a:p>
+            <a:pPr algn="l"/>
+            <a:r>
+              <a:rPr sz="1050" b="0">
                 <a:solidFill>
                   <a:srgbClr val="FFFFFF"/>
                 </a:solidFill>
                 <a:latin typeface="Calibri"/>
               </a:rPr>
-              <a:t>Identify one production APM environment
-to run the framework against.
-Onboarding takes &lt; 5 minutes.
-Baseline learns from live traffic automatically.</a:t>
-            </a:r>
-          </a:p>
-        </p:txBody>
-      </p:sp>
-      <p:sp>
-        <p:nvSpPr>
-          <p:cNvPr id="11" name="Rectangle 10"/>
+              <a:t>Behavioral baseline learning built into
+APM onboarding — a toggle, not a script.
+  •  Detections surface alongside AutoDetect
+       alerts in the Splunk UI
+  •  Same notification routing (PagerDuty,
+       Slack, webhook)
+  •  Same muting, SLO wiring, and RBAC
+  •  No external scripts or cron jobs</a:t>
+            </a:r>
+          </a:p>
+        </p:txBody>
+      </p:sp>
+      <p:sp>
+        <p:nvSpPr>
+          <p:cNvPr id="12" name="Rectangle 11"/>
           <p:cNvSpPr/>
           <p:nvPr/>
         </p:nvSpPr>
         <p:spPr>
           <a:xfrm>
-            <a:off x="3227832" y="960120"/>
-            <a:ext cx="2651760" cy="3291840"/>
+            <a:off x="3227832" y="1325880"/>
+            <a:ext cx="2651760" cy="3154680"/>
           </a:xfrm>
           <a:prstGeom prst="rect">
             <a:avLst/>
@@ -3717,13 +3756,13 @@
       </p:sp>
       <p:sp>
         <p:nvSpPr>
-          <p:cNvPr id="12" name="Rectangle 11"/>
+          <p:cNvPr id="13" name="Rectangle 12"/>
           <p:cNvSpPr/>
           <p:nvPr/>
         </p:nvSpPr>
         <p:spPr>
           <a:xfrm>
-            <a:off x="3227832" y="960120"/>
+            <a:off x="3227832" y="1325880"/>
             <a:ext cx="2651760" cy="54864"/>
           </a:xfrm>
           <a:prstGeom prst="rect">
@@ -3760,13 +3799,13 @@
       </p:sp>
       <p:sp>
         <p:nvSpPr>
-          <p:cNvPr id="13" name="Rectangle 12"/>
+          <p:cNvPr id="14" name="Rectangle 13"/>
           <p:cNvSpPr/>
           <p:nvPr/>
         </p:nvSpPr>
         <p:spPr>
           <a:xfrm>
-            <a:off x="3337560" y="1069848"/>
+            <a:off x="3337560" y="1417320"/>
             <a:ext cx="292608" cy="292608"/>
           </a:xfrm>
           <a:prstGeom prst="rect">
@@ -3803,13 +3842,13 @@
       </p:sp>
       <p:sp>
         <p:nvSpPr>
-          <p:cNvPr id="14" name="TextBox 13"/>
-          <p:cNvSpPr txBox="1"/>
-          <p:nvPr/>
-        </p:nvSpPr>
-        <p:spPr>
-          <a:xfrm>
-            <a:off x="3337560" y="1051560"/>
+          <p:cNvPr id="15" name="TextBox 14"/>
+          <p:cNvSpPr txBox="1"/>
+          <p:nvPr/>
+        </p:nvSpPr>
+        <p:spPr>
+          <a:xfrm>
+            <a:off x="3337560" y="1399032"/>
             <a:ext cx="292608" cy="320040"/>
           </a:xfrm>
           <a:prstGeom prst="rect">
@@ -3838,13 +3877,13 @@
       </p:sp>
       <p:sp>
         <p:nvSpPr>
-          <p:cNvPr id="15" name="TextBox 14"/>
-          <p:cNvSpPr txBox="1"/>
-          <p:nvPr/>
-        </p:nvSpPr>
-        <p:spPr>
-          <a:xfrm>
-            <a:off x="3703320" y="1051560"/>
+          <p:cNvPr id="16" name="TextBox 15"/>
+          <p:cNvSpPr txBox="1"/>
+          <p:nvPr/>
+        </p:nvSpPr>
+        <p:spPr>
+          <a:xfrm>
+            <a:off x="3703320" y="1399032"/>
             <a:ext cx="2057400" cy="384048"/>
           </a:xfrm>
           <a:prstGeom prst="rect">
@@ -3866,62 +3905,63 @@
                 </a:solidFill>
                 <a:latin typeface="Calibri"/>
               </a:rPr>
-              <a:t>UI + Notifications</a:t>
-            </a:r>
-          </a:p>
-        </p:txBody>
-      </p:sp>
-      <p:sp>
-        <p:nvSpPr>
-          <p:cNvPr id="16" name="TextBox 15"/>
-          <p:cNvSpPr txBox="1"/>
-          <p:nvPr/>
-        </p:nvSpPr>
-        <p:spPr>
-          <a:xfrm>
-            <a:off x="3337560" y="1508760"/>
-            <a:ext cx="2450592" cy="2651760"/>
-          </a:xfrm>
-          <a:prstGeom prst="rect">
-            <a:avLst/>
-          </a:prstGeom>
-          <a:noFill/>
-        </p:spPr>
-        <p:txBody>
-          <a:bodyPr wrap="square">
-            <a:spAutoFit/>
-          </a:bodyPr>
-          <a:lstStyle/>
-          <a:p>
-            <a:pPr algn="l"/>
-            <a:r>
-              <a:rPr sz="1100" b="0">
+              <a:t>AI Triage as a Product Feature</a:t>
+            </a:r>
+          </a:p>
+        </p:txBody>
+      </p:sp>
+      <p:sp>
+        <p:nvSpPr>
+          <p:cNvPr id="17" name="TextBox 16"/>
+          <p:cNvSpPr txBox="1"/>
+          <p:nvPr/>
+        </p:nvSpPr>
+        <p:spPr>
+          <a:xfrm>
+            <a:off x="3337560" y="1856232"/>
+            <a:ext cx="2450592" cy="2514600"/>
+          </a:xfrm>
+          <a:prstGeom prst="rect">
+            <a:avLst/>
+          </a:prstGeom>
+          <a:noFill/>
+        </p:spPr>
+        <p:txBody>
+          <a:bodyPr wrap="square">
+            <a:spAutoFit/>
+          </a:bodyPr>
+          <a:lstStyle/>
+          <a:p>
+            <a:pPr algn="l"/>
+            <a:r>
+              <a:rPr sz="1050" b="0">
                 <a:solidFill>
                   <a:srgbClr val="FFFFFF"/>
                 </a:solidFill>
                 <a:latin typeface="Calibri"/>
               </a:rPr>
-              <a:t>Today: detections log to alerts.log + Splunk
-custom events (visible on dashboard).
-Production target:
-  •  All alerts surfaced in Splunk UI
-  •  PagerDuty / Slack / webhook on INCIDENT
-  •  Triage summary attached to the alert
-  •  One-click runbook from the alert detail</a:t>
-            </a:r>
-          </a:p>
-        </p:txBody>
-      </p:sp>
-      <p:sp>
-        <p:nvSpPr>
-          <p:cNvPr id="17" name="Rectangle 16"/>
+              <a:t>Claude-generated verdict becomes the
+'Explain this alert' experience.
+  •  Every INCIDENT gets a triage summary
+       attached automatically
+  •  Root cause + affected services +
+       recommended action in plain English
+  •  Generated runbook linked from the
+       alert detail view</a:t>
+            </a:r>
+          </a:p>
+        </p:txBody>
+      </p:sp>
+      <p:sp>
+        <p:nvSpPr>
+          <p:cNvPr id="18" name="Rectangle 17"/>
           <p:cNvSpPr/>
           <p:nvPr/>
         </p:nvSpPr>
         <p:spPr>
           <a:xfrm>
-            <a:off x="6044184" y="960120"/>
-            <a:ext cx="2651760" cy="3291840"/>
+            <a:off x="6044184" y="1325880"/>
+            <a:ext cx="2651760" cy="3154680"/>
           </a:xfrm>
           <a:prstGeom prst="rect">
             <a:avLst/>
@@ -3957,13 +3997,13 @@
       </p:sp>
       <p:sp>
         <p:nvSpPr>
-          <p:cNvPr id="18" name="Rectangle 17"/>
+          <p:cNvPr id="19" name="Rectangle 18"/>
           <p:cNvSpPr/>
           <p:nvPr/>
         </p:nvSpPr>
         <p:spPr>
           <a:xfrm>
-            <a:off x="6044184" y="960120"/>
+            <a:off x="6044184" y="1325880"/>
             <a:ext cx="2651760" cy="54864"/>
           </a:xfrm>
           <a:prstGeom prst="rect">
@@ -4000,13 +4040,13 @@
       </p:sp>
       <p:sp>
         <p:nvSpPr>
-          <p:cNvPr id="19" name="Rectangle 18"/>
+          <p:cNvPr id="20" name="Rectangle 19"/>
           <p:cNvSpPr/>
           <p:nvPr/>
         </p:nvSpPr>
         <p:spPr>
           <a:xfrm>
-            <a:off x="6153912" y="1069848"/>
+            <a:off x="6153912" y="1417320"/>
             <a:ext cx="292608" cy="292608"/>
           </a:xfrm>
           <a:prstGeom prst="rect">
@@ -4043,13 +4083,13 @@
       </p:sp>
       <p:sp>
         <p:nvSpPr>
-          <p:cNvPr id="20" name="TextBox 19"/>
-          <p:cNvSpPr txBox="1"/>
-          <p:nvPr/>
-        </p:nvSpPr>
-        <p:spPr>
-          <a:xfrm>
-            <a:off x="6153912" y="1051560"/>
+          <p:cNvPr id="21" name="TextBox 20"/>
+          <p:cNvSpPr txBox="1"/>
+          <p:nvPr/>
+        </p:nvSpPr>
+        <p:spPr>
+          <a:xfrm>
+            <a:off x="6153912" y="1399032"/>
             <a:ext cx="292608" cy="320040"/>
           </a:xfrm>
           <a:prstGeom prst="rect">
@@ -4078,13 +4118,13 @@
       </p:sp>
       <p:sp>
         <p:nvSpPr>
-          <p:cNvPr id="21" name="TextBox 20"/>
-          <p:cNvSpPr txBox="1"/>
-          <p:nvPr/>
-        </p:nvSpPr>
-        <p:spPr>
-          <a:xfrm>
-            <a:off x="6519672" y="1051560"/>
+          <p:cNvPr id="22" name="TextBox 21"/>
+          <p:cNvSpPr txBox="1"/>
+          <p:nvPr/>
+        </p:nvSpPr>
+        <p:spPr>
+          <a:xfrm>
+            <a:off x="6519672" y="1399032"/>
             <a:ext cx="2057400" cy="384048"/>
           </a:xfrm>
           <a:prstGeom prst="rect">
@@ -4106,59 +4146,62 @@
                 </a:solidFill>
                 <a:latin typeface="Calibri"/>
               </a:rPr>
-              <a:t>Expand Coverage</a:t>
-            </a:r>
-          </a:p>
-        </p:txBody>
-      </p:sp>
-      <p:sp>
-        <p:nvSpPr>
-          <p:cNvPr id="22" name="TextBox 21"/>
-          <p:cNvSpPr txBox="1"/>
-          <p:nvPr/>
-        </p:nvSpPr>
-        <p:spPr>
-          <a:xfrm>
-            <a:off x="6153912" y="1508760"/>
-            <a:ext cx="2450592" cy="2651760"/>
-          </a:xfrm>
-          <a:prstGeom prst="rect">
-            <a:avLst/>
-          </a:prstGeom>
-          <a:noFill/>
-        </p:spPr>
-        <p:txBody>
-          <a:bodyPr wrap="square">
-            <a:spAutoFit/>
-          </a:bodyPr>
-          <a:lstStyle/>
-          <a:p>
-            <a:pPr algn="l"/>
-            <a:r>
-              <a:rPr sz="1100" b="0">
+              <a:t>Platform Differentiation</a:t>
+            </a:r>
+          </a:p>
+        </p:txBody>
+      </p:sp>
+      <p:sp>
+        <p:nvSpPr>
+          <p:cNvPr id="23" name="TextBox 22"/>
+          <p:cNvSpPr txBox="1"/>
+          <p:nvPr/>
+        </p:nvSpPr>
+        <p:spPr>
+          <a:xfrm>
+            <a:off x="6153912" y="1856232"/>
+            <a:ext cx="2450592" cy="2514600"/>
+          </a:xfrm>
+          <a:prstGeom prst="rect">
+            <a:avLst/>
+          </a:prstGeom>
+          <a:noFill/>
+        </p:spPr>
+        <p:txBody>
+          <a:bodyPr wrap="square">
+            <a:spAutoFit/>
+          </a:bodyPr>
+          <a:lstStyle/>
+          <a:p>
+            <a:pPr algn="l"/>
+            <a:r>
+              <a:rPr sz="1050" b="0">
                 <a:solidFill>
                   <a:srgbClr val="FFFFFF"/>
                 </a:solidFill>
                 <a:latin typeface="Calibri"/>
               </a:rPr>
-              <a:t>Once baseline is stable (1–2 days):
-  •  Run onboard --auto on all environments
-  •  Add CI/CD deployment hook
-  •  Enable dedup agent to suppress floods
-  •  Add SLO impact estimator to runbook</a:t>
-            </a:r>
-          </a:p>
-        </p:txBody>
-      </p:sp>
-      <p:sp>
-        <p:nvSpPr>
-          <p:cNvPr id="23" name="TextBox 22"/>
-          <p:cNvSpPr txBox="1"/>
-          <p:nvPr/>
-        </p:nvSpPr>
-        <p:spPr>
-          <a:xfrm>
-            <a:off x="411480" y="4370832"/>
+              <a:t>AutoDetect covers the metric layer.
+Every vendor covers the metric layer.
+  •  Structural + behavioral detection catches
+       failures that leave no metric fingerprint
+  •  First-occurrence detection — no threshold
+       to tune, fires on first event
+  •  Self-healing baseline — zero ops overhead
+  •  Defensible, differentiated capability</a:t>
+            </a:r>
+          </a:p>
+        </p:txBody>
+      </p:sp>
+      <p:sp>
+        <p:nvSpPr>
+          <p:cNvPr id="24" name="TextBox 23"/>
+          <p:cNvSpPr txBox="1"/>
+          <p:nvPr/>
+        </p:nvSpPr>
+        <p:spPr>
+          <a:xfrm>
+            <a:off x="411480" y="4553712"/>
             <a:ext cx="8412480" cy="320040"/>
           </a:xfrm>
           <a:prstGeom prst="rect">
@@ -4187,7 +4230,7 @@
       </p:sp>
       <p:sp>
         <p:nvSpPr>
-          <p:cNvPr id="24" name="TextBox 23"/>
+          <p:cNvPr id="25" name="TextBox 24"/>
           <p:cNvSpPr txBox="1"/>
           <p:nvPr/>
         </p:nvSpPr>

</xml_diff>

<commit_message>
Add PetClinic topology slide and talk track section
Inserts a new Slide 8 with a visual service topology diagram of the
Spring PetClinic demo environment (config-server, discovery-server,
admin-server, api-gateway, customers/vets/visits-service, petclinic-db)
and a corresponding talk track section orienting the audience to the
app before the demo agenda.

Co-Authored-By: Claude Opus 4.6 <noreply@anthropic.com>
</commit_message>
<xml_diff>
--- a/Behavioral_Baseline_Deck.pptx
+++ b/Behavioral_Baseline_Deck.pptx
@@ -15,6 +15,7 @@
     <p:sldId id="263" r:id="rId14"/>
     <p:sldId id="264" r:id="rId15"/>
     <p:sldId id="265" r:id="rId16"/>
+    <p:sldId id="266" r:id="rId17"/>
   </p:sldIdLst>
   <p:sldSz cx="9144000" cy="5148072" type="screen4x3"/>
   <p:notesSz cx="6858000" cy="9144000"/>
@@ -3323,6 +3324,145 @@
         <p:spPr>
           <a:xfrm>
             <a:off x="0" y="0"/>
+            <a:ext cx="320040" cy="5148072"/>
+          </a:xfrm>
+          <a:prstGeom prst="rect">
+            <a:avLst/>
+          </a:prstGeom>
+          <a:solidFill>
+            <a:srgbClr val="00BCEB"/>
+          </a:solidFill>
+          <a:ln>
+            <a:noFill/>
+          </a:ln>
+        </p:spPr>
+        <p:style>
+          <a:lnRef idx="1">
+            <a:schemeClr val="accent1"/>
+          </a:lnRef>
+          <a:fillRef idx="3">
+            <a:schemeClr val="accent1"/>
+          </a:fillRef>
+          <a:effectRef idx="2">
+            <a:schemeClr val="accent1"/>
+          </a:effectRef>
+          <a:fontRef idx="minor">
+            <a:schemeClr val="lt1"/>
+          </a:fontRef>
+        </p:style>
+        <p:txBody>
+          <a:bodyPr rtlCol="0" anchor="ctr"/>
+          <a:lstStyle/>
+          <a:p>
+            <a:pPr algn="ctr"/>
+          </a:p>
+        </p:txBody>
+      </p:sp>
+      <p:sp>
+        <p:nvSpPr>
+          <p:cNvPr id="3" name="TextBox 2"/>
+          <p:cNvSpPr txBox="1"/>
+          <p:nvPr/>
+        </p:nvSpPr>
+        <p:spPr>
+          <a:xfrm>
+            <a:off x="548640" y="1645920"/>
+            <a:ext cx="7772400" cy="1097280"/>
+          </a:xfrm>
+          <a:prstGeom prst="rect">
+            <a:avLst/>
+          </a:prstGeom>
+          <a:noFill/>
+        </p:spPr>
+        <p:txBody>
+          <a:bodyPr wrap="square">
+            <a:spAutoFit/>
+          </a:bodyPr>
+          <a:lstStyle/>
+          <a:p>
+            <a:pPr algn="l"/>
+            <a:r>
+              <a:rPr sz="5400" b="1">
+                <a:solidFill>
+                  <a:srgbClr val="00BCEB"/>
+                </a:solidFill>
+                <a:latin typeface="Calibri"/>
+              </a:rPr>
+              <a:t>Live Demo</a:t>
+            </a:r>
+          </a:p>
+        </p:txBody>
+      </p:sp>
+      <p:sp>
+        <p:nvSpPr>
+          <p:cNvPr id="4" name="TextBox 3"/>
+          <p:cNvSpPr txBox="1"/>
+          <p:nvPr/>
+        </p:nvSpPr>
+        <p:spPr>
+          <a:xfrm>
+            <a:off x="274320" y="4855464"/>
+            <a:ext cx="8595360" cy="256032"/>
+          </a:xfrm>
+          <a:prstGeom prst="rect">
+            <a:avLst/>
+          </a:prstGeom>
+          <a:noFill/>
+        </p:spPr>
+        <p:txBody>
+          <a:bodyPr wrap="square">
+            <a:spAutoFit/>
+          </a:bodyPr>
+          <a:lstStyle/>
+          <a:p>
+            <a:pPr algn="l"/>
+            <a:r>
+              <a:rPr sz="700" b="0">
+                <a:solidFill>
+                  <a:srgbClr val="AAC4D8"/>
+                </a:solidFill>
+                <a:latin typeface="Calibri"/>
+              </a:rPr>
+              <a:t>© 2025 Cisco and/or its affiliates. All rights reserved.   Cisco Confidential</a:t>
+            </a:r>
+          </a:p>
+        </p:txBody>
+      </p:sp>
+    </p:spTree>
+  </p:cSld>
+  <p:clrMapOvr>
+    <a:masterClrMapping/>
+  </p:clrMapOvr>
+</p:sld>
+</file>
+
+<file path=ppt/slides/slide11.xml><?xml version="1.0" encoding="utf-8"?>
+<p:sld xmlns:a="http://schemas.openxmlformats.org/drawingml/2006/main" xmlns:p="http://schemas.openxmlformats.org/presentationml/2006/main" xmlns:r="http://schemas.openxmlformats.org/officeDocument/2006/relationships">
+  <p:cSld>
+    <p:bg>
+      <p:bgPr>
+        <a:solidFill>
+          <a:srgbClr val="0D274D"/>
+        </a:solidFill>
+        <a:effectLst/>
+      </p:bgPr>
+    </p:bg>
+    <p:spTree>
+      <p:nvGrpSpPr>
+        <p:cNvPr id="1" name=""/>
+        <p:cNvGrpSpPr/>
+        <p:nvPr/>
+      </p:nvGrpSpPr>
+      <p:grpSpPr/>
+      <p:sp>
+        <p:nvSpPr>
+          <p:cNvPr id="2" name="Rectangle 1"/>
+          <p:cNvSpPr/>
+          <p:nvPr/>
+        </p:nvSpPr>
+        <p:spPr>
+          <a:xfrm>
+            <a:off x="0" y="0"/>
             <a:ext cx="164592" cy="5148072"/>
           </a:xfrm>
           <a:prstGeom prst="rect">
@@ -9761,7 +9901,7 @@
                 </a:solidFill>
                 <a:latin typeface="Calibri"/>
               </a:rPr>
-              <a:t>What We'll Demo Today</a:t>
+              <a:t>Demo Environment: Spring PetClinic on Kubernetes</a:t>
             </a:r>
           </a:p>
         </p:txBody>
@@ -9811,14 +9951,49 @@
       </p:sp>
       <p:sp>
         <p:nvSpPr>
-          <p:cNvPr id="5" name="Rectangle 4"/>
+          <p:cNvPr id="5" name="TextBox 4"/>
+          <p:cNvSpPr txBox="1"/>
+          <p:nvPr/>
+        </p:nvSpPr>
+        <p:spPr>
+          <a:xfrm>
+            <a:off x="411480" y="914400"/>
+            <a:ext cx="8412480" cy="347472"/>
+          </a:xfrm>
+          <a:prstGeom prst="rect">
+            <a:avLst/>
+          </a:prstGeom>
+          <a:noFill/>
+        </p:spPr>
+        <p:txBody>
+          <a:bodyPr wrap="square">
+            <a:spAutoFit/>
+          </a:bodyPr>
+          <a:lstStyle/>
+          <a:p>
+            <a:pPr algn="l"/>
+            <a:r>
+              <a:rPr sz="1200" b="0">
+                <a:solidFill>
+                  <a:srgbClr val="CCDDEE"/>
+                </a:solidFill>
+                <a:latin typeface="Calibri"/>
+              </a:rPr>
+              <a:t>All demos run against a live Spring PetClinic deployment on k3d (k8s). Splunk OTel Java agent auto-instruments every service.</a:t>
+            </a:r>
+          </a:p>
+        </p:txBody>
+      </p:sp>
+      <p:sp>
+        <p:nvSpPr>
+          <p:cNvPr id="6" name="Rectangle 5"/>
           <p:cNvSpPr/>
           <p:nvPr/>
         </p:nvSpPr>
         <p:spPr>
           <a:xfrm>
-            <a:off x="411480" y="969264"/>
-            <a:ext cx="8412480" cy="461772"/>
+            <a:off x="1371600" y="1371600"/>
+            <a:ext cx="1828800" cy="512064"/>
           </a:xfrm>
           <a:prstGeom prst="rect">
             <a:avLst/>
@@ -9854,14 +10029,57 @@
       </p:sp>
       <p:sp>
         <p:nvSpPr>
-          <p:cNvPr id="6" name="TextBox 5"/>
-          <p:cNvSpPr txBox="1"/>
-          <p:nvPr/>
-        </p:nvSpPr>
-        <p:spPr>
-          <a:xfrm>
-            <a:off x="484632" y="1014984"/>
-            <a:ext cx="914400" cy="384048"/>
+          <p:cNvPr id="7" name="Rectangle 6"/>
+          <p:cNvSpPr/>
+          <p:nvPr/>
+        </p:nvSpPr>
+        <p:spPr>
+          <a:xfrm>
+            <a:off x="1371600" y="1371600"/>
+            <a:ext cx="1828800" cy="45720"/>
+          </a:xfrm>
+          <a:prstGeom prst="rect">
+            <a:avLst/>
+          </a:prstGeom>
+          <a:solidFill>
+            <a:srgbClr val="CCD6E0"/>
+          </a:solidFill>
+          <a:ln>
+            <a:noFill/>
+          </a:ln>
+        </p:spPr>
+        <p:style>
+          <a:lnRef idx="1">
+            <a:schemeClr val="accent1"/>
+          </a:lnRef>
+          <a:fillRef idx="3">
+            <a:schemeClr val="accent1"/>
+          </a:fillRef>
+          <a:effectRef idx="2">
+            <a:schemeClr val="accent1"/>
+          </a:effectRef>
+          <a:fontRef idx="minor">
+            <a:schemeClr val="lt1"/>
+          </a:fontRef>
+        </p:style>
+        <p:txBody>
+          <a:bodyPr rtlCol="0" anchor="ctr"/>
+          <a:lstStyle/>
+          <a:p>
+            <a:pPr algn="ctr"/>
+          </a:p>
+        </p:txBody>
+      </p:sp>
+      <p:sp>
+        <p:nvSpPr>
+          <p:cNvPr id="8" name="TextBox 7"/>
+          <p:cNvSpPr txBox="1"/>
+          <p:nvPr/>
+        </p:nvSpPr>
+        <p:spPr>
+          <a:xfrm>
+            <a:off x="1463040" y="1435608"/>
+            <a:ext cx="1691640" cy="256032"/>
           </a:xfrm>
           <a:prstGeom prst="rect">
             <a:avLst/>
@@ -9878,81 +10096,11 @@
             <a:r>
               <a:rPr sz="1100" b="1">
                 <a:solidFill>
-                  <a:srgbClr val="00BCEB"/>
-                </a:solidFill>
-                <a:latin typeface="Calibri"/>
-              </a:rPr>
-              <a:t>Demo 0</a:t>
-            </a:r>
-          </a:p>
-        </p:txBody>
-      </p:sp>
-      <p:sp>
-        <p:nvSpPr>
-          <p:cNvPr id="7" name="TextBox 6"/>
-          <p:cNvSpPr txBox="1"/>
-          <p:nvPr/>
-        </p:nvSpPr>
-        <p:spPr>
-          <a:xfrm>
-            <a:off x="1463040" y="1014984"/>
-            <a:ext cx="1371600" cy="384048"/>
-          </a:xfrm>
-          <a:prstGeom prst="rect">
-            <a:avLst/>
-          </a:prstGeom>
-          <a:noFill/>
-        </p:spPr>
-        <p:txBody>
-          <a:bodyPr wrap="square">
-            <a:spAutoFit/>
-          </a:bodyPr>
-          <a:lstStyle/>
-          <a:p>
-            <a:pPr algn="l"/>
-            <a:r>
-              <a:rPr sz="1100" b="1">
-                <a:solidFill>
                   <a:srgbClr val="FFFFFF"/>
                 </a:solidFill>
                 <a:latin typeface="Calibri"/>
               </a:rPr>
-              <a:t>Steady State</a:t>
-            </a:r>
-          </a:p>
-        </p:txBody>
-      </p:sp>
-      <p:sp>
-        <p:nvSpPr>
-          <p:cNvPr id="8" name="TextBox 7"/>
-          <p:cNvSpPr txBox="1"/>
-          <p:nvPr/>
-        </p:nvSpPr>
-        <p:spPr>
-          <a:xfrm>
-            <a:off x="2926080" y="1014984"/>
-            <a:ext cx="5806440" cy="411480"/>
-          </a:xfrm>
-          <a:prstGeom prst="rect">
-            <a:avLst/>
-          </a:prstGeom>
-          <a:noFill/>
-        </p:spPr>
-        <p:txBody>
-          <a:bodyPr wrap="square">
-            <a:spAutoFit/>
-          </a:bodyPr>
-          <a:lstStyle/>
-          <a:p>
-            <a:pPr algn="l"/>
-            <a:r>
-              <a:rPr sz="1000" b="0">
-                <a:solidFill>
-                  <a:srgbClr val="BBCCDD"/>
-                </a:solidFill>
-                <a:latin typeface="Calibri"/>
-              </a:rPr>
-              <a:t>Framework in normal operation — baselines learned, cron running, zero anomalies</a:t>
+              <a:t>config-server</a:t>
             </a:r>
           </a:p>
         </p:txBody>
@@ -9965,113 +10113,43 @@
         </p:nvSpPr>
         <p:spPr>
           <a:xfrm>
-            <a:off x="484632" y="1504188"/>
-            <a:ext cx="914400" cy="384048"/>
-          </a:xfrm>
-          <a:prstGeom prst="rect">
-            <a:avLst/>
-          </a:prstGeom>
-          <a:noFill/>
-        </p:spPr>
-        <p:txBody>
-          <a:bodyPr wrap="square">
-            <a:spAutoFit/>
-          </a:bodyPr>
-          <a:lstStyle/>
-          <a:p>
-            <a:pPr algn="l"/>
-            <a:r>
-              <a:rPr sz="1100" b="1">
-                <a:solidFill>
-                  <a:srgbClr val="00BCEB"/>
-                </a:solidFill>
-                <a:latin typeface="Calibri"/>
-              </a:rPr>
-              <a:t>Demo 1</a:t>
-            </a:r>
-          </a:p>
-        </p:txBody>
-      </p:sp>
-      <p:sp>
-        <p:nvSpPr>
-          <p:cNvPr id="10" name="TextBox 9"/>
-          <p:cNvSpPr txBox="1"/>
-          <p:nvPr/>
-        </p:nvSpPr>
-        <p:spPr>
-          <a:xfrm>
-            <a:off x="1463040" y="1504188"/>
-            <a:ext cx="1371600" cy="384048"/>
-          </a:xfrm>
-          <a:prstGeom prst="rect">
-            <a:avLst/>
-          </a:prstGeom>
-          <a:noFill/>
-        </p:spPr>
-        <p:txBody>
-          <a:bodyPr wrap="square">
-            <a:spAutoFit/>
-          </a:bodyPr>
-          <a:lstStyle/>
-          <a:p>
-            <a:pPr algn="l"/>
-            <a:r>
-              <a:rPr sz="1100" b="1">
-                <a:solidFill>
-                  <a:srgbClr val="FFFFFF"/>
-                </a:solidFill>
-                <a:latin typeface="Calibri"/>
-              </a:rPr>
-              <a:t>DB Outage → New Error Signatures</a:t>
-            </a:r>
-          </a:p>
-        </p:txBody>
-      </p:sp>
-      <p:sp>
-        <p:nvSpPr>
-          <p:cNvPr id="11" name="TextBox 10"/>
-          <p:cNvSpPr txBox="1"/>
-          <p:nvPr/>
-        </p:nvSpPr>
-        <p:spPr>
-          <a:xfrm>
-            <a:off x="2926080" y="1504188"/>
-            <a:ext cx="5806440" cy="411480"/>
-          </a:xfrm>
-          <a:prstGeom prst="rect">
-            <a:avLst/>
-          </a:prstGeom>
-          <a:noFill/>
-        </p:spPr>
-        <p:txBody>
-          <a:bodyPr wrap="square">
-            <a:spAutoFit/>
-          </a:bodyPr>
-          <a:lstStyle/>
-          <a:p>
-            <a:pPr algn="l"/>
-            <a:r>
-              <a:rPr sz="1000" b="0">
-                <a:solidFill>
-                  <a:srgbClr val="BBCCDD"/>
-                </a:solidFill>
-                <a:latin typeface="Calibri"/>
-              </a:rPr>
-              <a:t>Database goes down. New CannotCreateTransactionException fires on first occurrence. Claude: INCIDENT, PAGE_ONCALL</a:t>
-            </a:r>
-          </a:p>
-        </p:txBody>
-      </p:sp>
-      <p:sp>
-        <p:nvSpPr>
-          <p:cNvPr id="12" name="Rectangle 11"/>
+            <a:off x="1463040" y="1664208"/>
+            <a:ext cx="1691640" cy="201168"/>
+          </a:xfrm>
+          <a:prstGeom prst="rect">
+            <a:avLst/>
+          </a:prstGeom>
+          <a:noFill/>
+        </p:spPr>
+        <p:txBody>
+          <a:bodyPr wrap="square">
+            <a:spAutoFit/>
+          </a:bodyPr>
+          <a:lstStyle/>
+          <a:p>
+            <a:pPr algn="l"/>
+            <a:r>
+              <a:rPr sz="900" b="0">
+                <a:solidFill>
+                  <a:srgbClr val="AAC4D8"/>
+                </a:solidFill>
+                <a:latin typeface="Calibri"/>
+              </a:rPr>
+              <a:t>Spring Cloud Config</a:t>
+            </a:r>
+          </a:p>
+        </p:txBody>
+      </p:sp>
+      <p:sp>
+        <p:nvSpPr>
+          <p:cNvPr id="10" name="Rectangle 9"/>
           <p:cNvSpPr/>
           <p:nvPr/>
         </p:nvSpPr>
         <p:spPr>
           <a:xfrm>
-            <a:off x="411480" y="1947672"/>
-            <a:ext cx="8412480" cy="461772"/>
+            <a:off x="3657600" y="1371600"/>
+            <a:ext cx="1828800" cy="512064"/>
           </a:xfrm>
           <a:prstGeom prst="rect">
             <a:avLst/>
@@ -10107,224 +10185,127 @@
       </p:sp>
       <p:sp>
         <p:nvSpPr>
+          <p:cNvPr id="11" name="Rectangle 10"/>
+          <p:cNvSpPr/>
+          <p:nvPr/>
+        </p:nvSpPr>
+        <p:spPr>
+          <a:xfrm>
+            <a:off x="3657600" y="1371600"/>
+            <a:ext cx="1828800" cy="45720"/>
+          </a:xfrm>
+          <a:prstGeom prst="rect">
+            <a:avLst/>
+          </a:prstGeom>
+          <a:solidFill>
+            <a:srgbClr val="CCD6E0"/>
+          </a:solidFill>
+          <a:ln>
+            <a:noFill/>
+          </a:ln>
+        </p:spPr>
+        <p:style>
+          <a:lnRef idx="1">
+            <a:schemeClr val="accent1"/>
+          </a:lnRef>
+          <a:fillRef idx="3">
+            <a:schemeClr val="accent1"/>
+          </a:fillRef>
+          <a:effectRef idx="2">
+            <a:schemeClr val="accent1"/>
+          </a:effectRef>
+          <a:fontRef idx="minor">
+            <a:schemeClr val="lt1"/>
+          </a:fontRef>
+        </p:style>
+        <p:txBody>
+          <a:bodyPr rtlCol="0" anchor="ctr"/>
+          <a:lstStyle/>
+          <a:p>
+            <a:pPr algn="ctr"/>
+          </a:p>
+        </p:txBody>
+      </p:sp>
+      <p:sp>
+        <p:nvSpPr>
+          <p:cNvPr id="12" name="TextBox 11"/>
+          <p:cNvSpPr txBox="1"/>
+          <p:nvPr/>
+        </p:nvSpPr>
+        <p:spPr>
+          <a:xfrm>
+            <a:off x="3749040" y="1435608"/>
+            <a:ext cx="1691640" cy="256032"/>
+          </a:xfrm>
+          <a:prstGeom prst="rect">
+            <a:avLst/>
+          </a:prstGeom>
+          <a:noFill/>
+        </p:spPr>
+        <p:txBody>
+          <a:bodyPr wrap="square">
+            <a:spAutoFit/>
+          </a:bodyPr>
+          <a:lstStyle/>
+          <a:p>
+            <a:pPr algn="l"/>
+            <a:r>
+              <a:rPr sz="1100" b="1">
+                <a:solidFill>
+                  <a:srgbClr val="FFFFFF"/>
+                </a:solidFill>
+                <a:latin typeface="Calibri"/>
+              </a:rPr>
+              <a:t>discovery-server</a:t>
+            </a:r>
+          </a:p>
+        </p:txBody>
+      </p:sp>
+      <p:sp>
+        <p:nvSpPr>
           <p:cNvPr id="13" name="TextBox 12"/>
           <p:cNvSpPr txBox="1"/>
           <p:nvPr/>
         </p:nvSpPr>
         <p:spPr>
           <a:xfrm>
-            <a:off x="484632" y="1993392"/>
-            <a:ext cx="914400" cy="384048"/>
-          </a:xfrm>
-          <a:prstGeom prst="rect">
-            <a:avLst/>
-          </a:prstGeom>
-          <a:noFill/>
-        </p:spPr>
-        <p:txBody>
-          <a:bodyPr wrap="square">
-            <a:spAutoFit/>
-          </a:bodyPr>
-          <a:lstStyle/>
-          <a:p>
-            <a:pPr algn="l"/>
-            <a:r>
-              <a:rPr sz="1100" b="1">
-                <a:solidFill>
-                  <a:srgbClr val="00BCEB"/>
-                </a:solidFill>
-                <a:latin typeface="Calibri"/>
-              </a:rPr>
-              <a:t>Demo 2</a:t>
-            </a:r>
-          </a:p>
-        </p:txBody>
-      </p:sp>
-      <p:sp>
-        <p:nvSpPr>
-          <p:cNvPr id="14" name="TextBox 13"/>
-          <p:cNvSpPr txBox="1"/>
-          <p:nvPr/>
-        </p:nvSpPr>
-        <p:spPr>
-          <a:xfrm>
-            <a:off x="1463040" y="1993392"/>
-            <a:ext cx="1371600" cy="384048"/>
-          </a:xfrm>
-          <a:prstGeom prst="rect">
-            <a:avLst/>
-          </a:prstGeom>
-          <a:noFill/>
-        </p:spPr>
-        <p:txBody>
-          <a:bodyPr wrap="square">
-            <a:spAutoFit/>
-          </a:bodyPr>
-          <a:lstStyle/>
-          <a:p>
-            <a:pPr algn="l"/>
-            <a:r>
-              <a:rPr sz="1100" b="1">
-                <a:solidFill>
-                  <a:srgbClr val="FFFFFF"/>
-                </a:solidFill>
-                <a:latin typeface="Calibri"/>
-              </a:rPr>
-              <a:t>Bad Deploy → First-Occurrence Error</a:t>
-            </a:r>
-          </a:p>
-        </p:txBody>
-      </p:sp>
-      <p:sp>
-        <p:nvSpPr>
-          <p:cNvPr id="15" name="TextBox 14"/>
-          <p:cNvSpPr txBox="1"/>
-          <p:nvPr/>
-        </p:nvSpPr>
-        <p:spPr>
-          <a:xfrm>
-            <a:off x="2926080" y="1993392"/>
-            <a:ext cx="5806440" cy="411480"/>
-          </a:xfrm>
-          <a:prstGeom prst="rect">
-            <a:avLst/>
-          </a:prstGeom>
-          <a:noFill/>
-        </p:spPr>
-        <p:txBody>
-          <a:bodyPr wrap="square">
-            <a:spAutoFit/>
-          </a:bodyPr>
-          <a:lstStyle/>
-          <a:p>
-            <a:pPr algn="l"/>
-            <a:r>
-              <a:rPr sz="1000" b="0">
-                <a:solidFill>
-                  <a:srgbClr val="BBCCDD"/>
-                </a:solidFill>
-                <a:latin typeface="Calibri"/>
-              </a:rPr>
-              <a:t>visits-service crashes on startup. First request to the dead service triggers detection. No threshold exceeded</a:t>
-            </a:r>
-          </a:p>
-        </p:txBody>
-      </p:sp>
-      <p:sp>
-        <p:nvSpPr>
-          <p:cNvPr id="16" name="TextBox 15"/>
-          <p:cNvSpPr txBox="1"/>
-          <p:nvPr/>
-        </p:nvSpPr>
-        <p:spPr>
-          <a:xfrm>
-            <a:off x="484632" y="2482596"/>
-            <a:ext cx="914400" cy="384048"/>
-          </a:xfrm>
-          <a:prstGeom prst="rect">
-            <a:avLst/>
-          </a:prstGeom>
-          <a:noFill/>
-        </p:spPr>
-        <p:txBody>
-          <a:bodyPr wrap="square">
-            <a:spAutoFit/>
-          </a:bodyPr>
-          <a:lstStyle/>
-          <a:p>
-            <a:pPr algn="l"/>
-            <a:r>
-              <a:rPr sz="1100" b="1">
-                <a:solidFill>
-                  <a:srgbClr val="00BCEB"/>
-                </a:solidFill>
-                <a:latin typeface="Calibri"/>
-              </a:rPr>
-              <a:t>Demo 3</a:t>
-            </a:r>
-          </a:p>
-        </p:txBody>
-      </p:sp>
-      <p:sp>
-        <p:nvSpPr>
-          <p:cNvPr id="17" name="TextBox 16"/>
-          <p:cNvSpPr txBox="1"/>
-          <p:nvPr/>
-        </p:nvSpPr>
-        <p:spPr>
-          <a:xfrm>
-            <a:off x="1463040" y="2482596"/>
-            <a:ext cx="1371600" cy="384048"/>
-          </a:xfrm>
-          <a:prstGeom prst="rect">
-            <a:avLst/>
-          </a:prstGeom>
-          <a:noFill/>
-        </p:spPr>
-        <p:txBody>
-          <a:bodyPr wrap="square">
-            <a:spAutoFit/>
-          </a:bodyPr>
-          <a:lstStyle/>
-          <a:p>
-            <a:pPr algn="l"/>
-            <a:r>
-              <a:rPr sz="1100" b="1">
-                <a:solidFill>
-                  <a:srgbClr val="FFFFFF"/>
-                </a:solidFill>
-                <a:latin typeface="Calibri"/>
-              </a:rPr>
-              <a:t>Missing Service → AI Triage</a:t>
-            </a:r>
-          </a:p>
-        </p:txBody>
-      </p:sp>
-      <p:sp>
-        <p:nvSpPr>
-          <p:cNvPr id="18" name="TextBox 17"/>
-          <p:cNvSpPr txBox="1"/>
-          <p:nvPr/>
-        </p:nvSpPr>
-        <p:spPr>
-          <a:xfrm>
-            <a:off x="2926080" y="2482596"/>
-            <a:ext cx="5806440" cy="411480"/>
-          </a:xfrm>
-          <a:prstGeom prst="rect">
-            <a:avLst/>
-          </a:prstGeom>
-          <a:noFill/>
-        </p:spPr>
-        <p:txBody>
-          <a:bodyPr wrap="square">
-            <a:spAutoFit/>
-          </a:bodyPr>
-          <a:lstStyle/>
-          <a:p>
-            <a:pPr algn="l"/>
-            <a:r>
-              <a:rPr sz="1000" b="0">
-                <a:solidFill>
-                  <a:srgbClr val="BBCCDD"/>
-                </a:solidFill>
-                <a:latin typeface="Calibri"/>
-              </a:rPr>
-              <a:t>vets-service killed. Framework detects structural absence from traces. Claude produces root cause + action in 3 min</a:t>
-            </a:r>
-          </a:p>
-        </p:txBody>
-      </p:sp>
-      <p:sp>
-        <p:nvSpPr>
-          <p:cNvPr id="19" name="Rectangle 18"/>
+            <a:off x="3749040" y="1664208"/>
+            <a:ext cx="1691640" cy="201168"/>
+          </a:xfrm>
+          <a:prstGeom prst="rect">
+            <a:avLst/>
+          </a:prstGeom>
+          <a:noFill/>
+        </p:spPr>
+        <p:txBody>
+          <a:bodyPr wrap="square">
+            <a:spAutoFit/>
+          </a:bodyPr>
+          <a:lstStyle/>
+          <a:p>
+            <a:pPr algn="l"/>
+            <a:r>
+              <a:rPr sz="900" b="0">
+                <a:solidFill>
+                  <a:srgbClr val="AAC4D8"/>
+                </a:solidFill>
+                <a:latin typeface="Calibri"/>
+              </a:rPr>
+              <a:t>Eureka Service Registry</a:t>
+            </a:r>
+          </a:p>
+        </p:txBody>
+      </p:sp>
+      <p:sp>
+        <p:nvSpPr>
+          <p:cNvPr id="14" name="Rectangle 13"/>
           <p:cNvSpPr/>
           <p:nvPr/>
         </p:nvSpPr>
         <p:spPr>
           <a:xfrm>
-            <a:off x="411480" y="2926080"/>
-            <a:ext cx="8412480" cy="461772"/>
+            <a:off x="5943600" y="1371600"/>
+            <a:ext cx="1828800" cy="512064"/>
           </a:xfrm>
           <a:prstGeom prst="rect">
             <a:avLst/>
@@ -10360,230 +10341,20 @@
       </p:sp>
       <p:sp>
         <p:nvSpPr>
-          <p:cNvPr id="20" name="TextBox 19"/>
-          <p:cNvSpPr txBox="1"/>
-          <p:nvPr/>
-        </p:nvSpPr>
-        <p:spPr>
-          <a:xfrm>
-            <a:off x="484632" y="2971800"/>
-            <a:ext cx="914400" cy="384048"/>
-          </a:xfrm>
-          <a:prstGeom prst="rect">
-            <a:avLst/>
-          </a:prstGeom>
-          <a:noFill/>
-        </p:spPr>
-        <p:txBody>
-          <a:bodyPr wrap="square">
-            <a:spAutoFit/>
-          </a:bodyPr>
-          <a:lstStyle/>
-          <a:p>
-            <a:pPr algn="l"/>
-            <a:r>
-              <a:rPr sz="1100" b="1">
-                <a:solidFill>
-                  <a:srgbClr val="00BCEB"/>
-                </a:solidFill>
-                <a:latin typeface="Calibri"/>
-              </a:rPr>
-              <a:t>Demo 4</a:t>
-            </a:r>
-          </a:p>
-        </p:txBody>
-      </p:sp>
-      <p:sp>
-        <p:nvSpPr>
-          <p:cNvPr id="21" name="TextBox 20"/>
-          <p:cNvSpPr txBox="1"/>
-          <p:nvPr/>
-        </p:nvSpPr>
-        <p:spPr>
-          <a:xfrm>
-            <a:off x="1463040" y="2971800"/>
-            <a:ext cx="1371600" cy="384048"/>
-          </a:xfrm>
-          <a:prstGeom prst="rect">
-            <a:avLst/>
-          </a:prstGeom>
-          <a:noFill/>
-        </p:spPr>
-        <p:txBody>
-          <a:bodyPr wrap="square">
-            <a:spAutoFit/>
-          </a:bodyPr>
-          <a:lstStyle/>
-          <a:p>
-            <a:pPr algn="l"/>
-            <a:r>
-              <a:rPr sz="1100" b="1">
-                <a:solidFill>
-                  <a:srgbClr val="FFFFFF"/>
-                </a:solidFill>
-                <a:latin typeface="Calibri"/>
-              </a:rPr>
-              <a:t>All-Tier Correlation</a:t>
-            </a:r>
-          </a:p>
-        </p:txBody>
-      </p:sp>
-      <p:sp>
-        <p:nvSpPr>
-          <p:cNvPr id="22" name="TextBox 21"/>
-          <p:cNvSpPr txBox="1"/>
-          <p:nvPr/>
-        </p:nvSpPr>
-        <p:spPr>
-          <a:xfrm>
-            <a:off x="2926080" y="2971800"/>
-            <a:ext cx="5806440" cy="411480"/>
-          </a:xfrm>
-          <a:prstGeom prst="rect">
-            <a:avLst/>
-          </a:prstGeom>
-          <a:noFill/>
-        </p:spPr>
-        <p:txBody>
-          <a:bodyPr wrap="square">
-            <a:spAutoFit/>
-          </a:bodyPr>
-          <a:lstStyle/>
-          <a:p>
-            <a:pPr algn="l"/>
-            <a:r>
-              <a:rPr sz="1000" b="0">
-                <a:solidFill>
-                  <a:srgbClr val="BBCCDD"/>
-                </a:solidFill>
-                <a:latin typeface="Calibri"/>
-              </a:rPr>
-              <a:t>Both vets-service and DB down simultaneously. AutoDetect + trace drift + error signatures → [Critical] MULTI_TIER</a:t>
-            </a:r>
-          </a:p>
-        </p:txBody>
-      </p:sp>
-      <p:sp>
-        <p:nvSpPr>
-          <p:cNvPr id="23" name="TextBox 22"/>
-          <p:cNvSpPr txBox="1"/>
-          <p:nvPr/>
-        </p:nvSpPr>
-        <p:spPr>
-          <a:xfrm>
-            <a:off x="484632" y="3461004"/>
-            <a:ext cx="914400" cy="384048"/>
-          </a:xfrm>
-          <a:prstGeom prst="rect">
-            <a:avLst/>
-          </a:prstGeom>
-          <a:noFill/>
-        </p:spPr>
-        <p:txBody>
-          <a:bodyPr wrap="square">
-            <a:spAutoFit/>
-          </a:bodyPr>
-          <a:lstStyle/>
-          <a:p>
-            <a:pPr algn="l"/>
-            <a:r>
-              <a:rPr sz="1100" b="1">
-                <a:solidFill>
-                  <a:srgbClr val="00BCEB"/>
-                </a:solidFill>
-                <a:latin typeface="Calibri"/>
-              </a:rPr>
-              <a:t>Demo 5</a:t>
-            </a:r>
-          </a:p>
-        </p:txBody>
-      </p:sp>
-      <p:sp>
-        <p:nvSpPr>
-          <p:cNvPr id="24" name="TextBox 23"/>
-          <p:cNvSpPr txBox="1"/>
-          <p:nvPr/>
-        </p:nvSpPr>
-        <p:spPr>
-          <a:xfrm>
-            <a:off x="1463040" y="3461004"/>
-            <a:ext cx="1371600" cy="384048"/>
-          </a:xfrm>
-          <a:prstGeom prst="rect">
-            <a:avLst/>
-          </a:prstGeom>
-          <a:noFill/>
-        </p:spPr>
-        <p:txBody>
-          <a:bodyPr wrap="square">
-            <a:spAutoFit/>
-          </a:bodyPr>
-          <a:lstStyle/>
-          <a:p>
-            <a:pPr algn="l"/>
-            <a:r>
-              <a:rPr sz="1100" b="1">
-                <a:solidFill>
-                  <a:srgbClr val="FFFFFF"/>
-                </a:solidFill>
-                <a:latin typeface="Calibri"/>
-              </a:rPr>
-              <a:t>Deploy-Correlated Severity Downgrade</a:t>
-            </a:r>
-          </a:p>
-        </p:txBody>
-      </p:sp>
-      <p:sp>
-        <p:nvSpPr>
-          <p:cNvPr id="25" name="TextBox 24"/>
-          <p:cNvSpPr txBox="1"/>
-          <p:nvPr/>
-        </p:nvSpPr>
-        <p:spPr>
-          <a:xfrm>
-            <a:off x="2926080" y="3461004"/>
-            <a:ext cx="5806440" cy="411480"/>
-          </a:xfrm>
-          <a:prstGeom prst="rect">
-            <a:avLst/>
-          </a:prstGeom>
-          <a:noFill/>
-        </p:spPr>
-        <p:txBody>
-          <a:bodyPr wrap="square">
-            <a:spAutoFit/>
-          </a:bodyPr>
-          <a:lstStyle/>
-          <a:p>
-            <a:pPr algn="l"/>
-            <a:r>
-              <a:rPr sz="1000" b="0">
-                <a:solidFill>
-                  <a:srgbClr val="BBCCDD"/>
-                </a:solidFill>
-                <a:latin typeface="Calibri"/>
-              </a:rPr>
-              <a:t>Bad deploy announced via CI/CD hook. correlate.py finds the deployment event and downgrades Major → Minor</a:t>
-            </a:r>
-          </a:p>
-        </p:txBody>
-      </p:sp>
-      <p:sp>
-        <p:nvSpPr>
-          <p:cNvPr id="26" name="Rectangle 25"/>
+          <p:cNvPr id="15" name="Rectangle 14"/>
           <p:cNvSpPr/>
           <p:nvPr/>
         </p:nvSpPr>
         <p:spPr>
           <a:xfrm>
-            <a:off x="411480" y="3904488"/>
-            <a:ext cx="8412480" cy="461772"/>
+            <a:off x="5943600" y="1371600"/>
+            <a:ext cx="1828800" cy="45720"/>
           </a:xfrm>
           <a:prstGeom prst="rect">
             <a:avLst/>
           </a:prstGeom>
           <a:solidFill>
-            <a:srgbClr val="334E68"/>
+            <a:srgbClr val="CCD6E0"/>
           </a:solidFill>
           <a:ln>
             <a:noFill/>
@@ -10613,14 +10384,14 @@
       </p:sp>
       <p:sp>
         <p:nvSpPr>
-          <p:cNvPr id="27" name="TextBox 26"/>
-          <p:cNvSpPr txBox="1"/>
-          <p:nvPr/>
-        </p:nvSpPr>
-        <p:spPr>
-          <a:xfrm>
-            <a:off x="484632" y="3950208"/>
-            <a:ext cx="914400" cy="384048"/>
+          <p:cNvPr id="16" name="TextBox 15"/>
+          <p:cNvSpPr txBox="1"/>
+          <p:nvPr/>
+        </p:nvSpPr>
+        <p:spPr>
+          <a:xfrm>
+            <a:off x="6035040" y="1435608"/>
+            <a:ext cx="1691640" cy="256032"/>
           </a:xfrm>
           <a:prstGeom prst="rect">
             <a:avLst/>
@@ -10637,25 +10408,146 @@
             <a:r>
               <a:rPr sz="1100" b="1">
                 <a:solidFill>
-                  <a:srgbClr val="00BCEB"/>
-                </a:solidFill>
-                <a:latin typeface="Calibri"/>
-              </a:rPr>
-              <a:t>Demo 6</a:t>
-            </a:r>
-          </a:p>
-        </p:txBody>
-      </p:sp>
-      <p:sp>
-        <p:nvSpPr>
-          <p:cNvPr id="28" name="TextBox 27"/>
-          <p:cNvSpPr txBox="1"/>
-          <p:nvPr/>
-        </p:nvSpPr>
-        <p:spPr>
-          <a:xfrm>
-            <a:off x="1463040" y="3950208"/>
-            <a:ext cx="1371600" cy="384048"/>
+                  <a:srgbClr val="FFFFFF"/>
+                </a:solidFill>
+                <a:latin typeface="Calibri"/>
+              </a:rPr>
+              <a:t>admin-server</a:t>
+            </a:r>
+          </a:p>
+        </p:txBody>
+      </p:sp>
+      <p:sp>
+        <p:nvSpPr>
+          <p:cNvPr id="17" name="TextBox 16"/>
+          <p:cNvSpPr txBox="1"/>
+          <p:nvPr/>
+        </p:nvSpPr>
+        <p:spPr>
+          <a:xfrm>
+            <a:off x="6035040" y="1664208"/>
+            <a:ext cx="1691640" cy="201168"/>
+          </a:xfrm>
+          <a:prstGeom prst="rect">
+            <a:avLst/>
+          </a:prstGeom>
+          <a:noFill/>
+        </p:spPr>
+        <p:txBody>
+          <a:bodyPr wrap="square">
+            <a:spAutoFit/>
+          </a:bodyPr>
+          <a:lstStyle/>
+          <a:p>
+            <a:pPr algn="l"/>
+            <a:r>
+              <a:rPr sz="900" b="0">
+                <a:solidFill>
+                  <a:srgbClr val="AAC4D8"/>
+                </a:solidFill>
+                <a:latin typeface="Calibri"/>
+              </a:rPr>
+              <a:t>Spring Boot Admin</a:t>
+            </a:r>
+          </a:p>
+        </p:txBody>
+      </p:sp>
+      <p:sp>
+        <p:nvSpPr>
+          <p:cNvPr id="18" name="Rectangle 17"/>
+          <p:cNvSpPr/>
+          <p:nvPr/>
+        </p:nvSpPr>
+        <p:spPr>
+          <a:xfrm>
+            <a:off x="3429000" y="2057400"/>
+            <a:ext cx="1828800" cy="512064"/>
+          </a:xfrm>
+          <a:prstGeom prst="rect">
+            <a:avLst/>
+          </a:prstGeom>
+          <a:solidFill>
+            <a:srgbClr val="1A5C4A"/>
+          </a:solidFill>
+          <a:ln>
+            <a:noFill/>
+          </a:ln>
+        </p:spPr>
+        <p:style>
+          <a:lnRef idx="1">
+            <a:schemeClr val="accent1"/>
+          </a:lnRef>
+          <a:fillRef idx="3">
+            <a:schemeClr val="accent1"/>
+          </a:fillRef>
+          <a:effectRef idx="2">
+            <a:schemeClr val="accent1"/>
+          </a:effectRef>
+          <a:fontRef idx="minor">
+            <a:schemeClr val="lt1"/>
+          </a:fontRef>
+        </p:style>
+        <p:txBody>
+          <a:bodyPr rtlCol="0" anchor="ctr"/>
+          <a:lstStyle/>
+          <a:p>
+            <a:pPr algn="ctr"/>
+          </a:p>
+        </p:txBody>
+      </p:sp>
+      <p:sp>
+        <p:nvSpPr>
+          <p:cNvPr id="19" name="Rectangle 18"/>
+          <p:cNvSpPr/>
+          <p:nvPr/>
+        </p:nvSpPr>
+        <p:spPr>
+          <a:xfrm>
+            <a:off x="3429000" y="2057400"/>
+            <a:ext cx="1828800" cy="45720"/>
+          </a:xfrm>
+          <a:prstGeom prst="rect">
+            <a:avLst/>
+          </a:prstGeom>
+          <a:solidFill>
+            <a:srgbClr val="00BCEB"/>
+          </a:solidFill>
+          <a:ln>
+            <a:noFill/>
+          </a:ln>
+        </p:spPr>
+        <p:style>
+          <a:lnRef idx="1">
+            <a:schemeClr val="accent1"/>
+          </a:lnRef>
+          <a:fillRef idx="3">
+            <a:schemeClr val="accent1"/>
+          </a:fillRef>
+          <a:effectRef idx="2">
+            <a:schemeClr val="accent1"/>
+          </a:effectRef>
+          <a:fontRef idx="minor">
+            <a:schemeClr val="lt1"/>
+          </a:fontRef>
+        </p:style>
+        <p:txBody>
+          <a:bodyPr rtlCol="0" anchor="ctr"/>
+          <a:lstStyle/>
+          <a:p>
+            <a:pPr algn="ctr"/>
+          </a:p>
+        </p:txBody>
+      </p:sp>
+      <p:sp>
+        <p:nvSpPr>
+          <p:cNvPr id="20" name="TextBox 19"/>
+          <p:cNvSpPr txBox="1"/>
+          <p:nvPr/>
+        </p:nvSpPr>
+        <p:spPr>
+          <a:xfrm>
+            <a:off x="3520440" y="2121408"/>
+            <a:ext cx="1691640" cy="256032"/>
           </a:xfrm>
           <a:prstGeom prst="rect">
             <a:avLst/>
@@ -10676,161 +10568,56 @@
                 </a:solidFill>
                 <a:latin typeface="Calibri"/>
               </a:rPr>
-              <a:t>Self-Healing</a:t>
-            </a:r>
-          </a:p>
-        </p:txBody>
-      </p:sp>
-      <p:sp>
-        <p:nvSpPr>
-          <p:cNvPr id="29" name="TextBox 28"/>
-          <p:cNvSpPr txBox="1"/>
-          <p:nvPr/>
-        </p:nvSpPr>
-        <p:spPr>
-          <a:xfrm>
-            <a:off x="2926080" y="3950208"/>
-            <a:ext cx="5806440" cy="411480"/>
-          </a:xfrm>
-          <a:prstGeom prst="rect">
-            <a:avLst/>
-          </a:prstGeom>
-          <a:noFill/>
-        </p:spPr>
-        <p:txBody>
-          <a:bodyPr wrap="square">
-            <a:spAutoFit/>
-          </a:bodyPr>
-          <a:lstStyle/>
-          <a:p>
-            <a:pPr algn="l"/>
-            <a:r>
-              <a:rPr sz="1000" b="0">
-                <a:solidFill>
-                  <a:srgbClr val="BBCCDD"/>
-                </a:solidFill>
-                <a:latin typeface="Calibri"/>
-              </a:rPr>
-              <a:t>New call path auto-promoted after 2 clean watch runs. Baseline healer scores windows and re-learns autonomously</a:t>
-            </a:r>
-          </a:p>
-        </p:txBody>
-      </p:sp>
-      <p:sp>
-        <p:nvSpPr>
-          <p:cNvPr id="30" name="TextBox 29"/>
-          <p:cNvSpPr txBox="1"/>
-          <p:nvPr/>
-        </p:nvSpPr>
-        <p:spPr>
-          <a:xfrm>
-            <a:off x="484632" y="4439412"/>
-            <a:ext cx="914400" cy="384048"/>
-          </a:xfrm>
-          <a:prstGeom prst="rect">
-            <a:avLst/>
-          </a:prstGeom>
-          <a:noFill/>
-        </p:spPr>
-        <p:txBody>
-          <a:bodyPr wrap="square">
-            <a:spAutoFit/>
-          </a:bodyPr>
-          <a:lstStyle/>
-          <a:p>
-            <a:pPr algn="l"/>
-            <a:r>
-              <a:rPr sz="1100" b="1">
-                <a:solidFill>
-                  <a:srgbClr val="00BCEB"/>
-                </a:solidFill>
-                <a:latin typeface="Calibri"/>
-              </a:rPr>
-              <a:t>Demo 7</a:t>
-            </a:r>
-          </a:p>
-        </p:txBody>
-      </p:sp>
-      <p:sp>
-        <p:nvSpPr>
-          <p:cNvPr id="31" name="TextBox 30"/>
-          <p:cNvSpPr txBox="1"/>
-          <p:nvPr/>
-        </p:nvSpPr>
-        <p:spPr>
-          <a:xfrm>
-            <a:off x="1463040" y="4439412"/>
-            <a:ext cx="1371600" cy="384048"/>
-          </a:xfrm>
-          <a:prstGeom prst="rect">
-            <a:avLst/>
-          </a:prstGeom>
-          <a:noFill/>
-        </p:spPr>
-        <p:txBody>
-          <a:bodyPr wrap="square">
-            <a:spAutoFit/>
-          </a:bodyPr>
-          <a:lstStyle/>
-          <a:p>
-            <a:pPr algn="l"/>
-            <a:r>
-              <a:rPr sz="1100" b="1">
-                <a:solidFill>
-                  <a:srgbClr val="FFFFFF"/>
-                </a:solidFill>
-                <a:latin typeface="Calibri"/>
-              </a:rPr>
-              <a:t>Auto-Onboarding</a:t>
-            </a:r>
-          </a:p>
-        </p:txBody>
-      </p:sp>
-      <p:sp>
-        <p:nvSpPr>
-          <p:cNvPr id="32" name="TextBox 31"/>
-          <p:cNvSpPr txBox="1"/>
-          <p:nvPr/>
-        </p:nvSpPr>
-        <p:spPr>
-          <a:xfrm>
-            <a:off x="2926080" y="4439412"/>
-            <a:ext cx="5806440" cy="411480"/>
-          </a:xfrm>
-          <a:prstGeom prst="rect">
-            <a:avLst/>
-          </a:prstGeom>
-          <a:noFill/>
-        </p:spPr>
-        <p:txBody>
-          <a:bodyPr wrap="square">
-            <a:spAutoFit/>
-          </a:bodyPr>
-          <a:lstStyle/>
-          <a:p>
-            <a:pPr algn="l"/>
-            <a:r>
-              <a:rPr sz="1000" b="0">
-                <a:solidFill>
-                  <a:srgbClr val="BBCCDD"/>
-                </a:solidFill>
-                <a:latin typeface="Calibri"/>
-              </a:rPr>
-              <a:t>New environment discovered. Baselines built, dashboard created, cron scheduled, runbook generated — in 60 seconds</a:t>
-            </a:r>
-          </a:p>
-        </p:txBody>
-      </p:sp>
-      <p:sp>
-        <p:nvSpPr>
-          <p:cNvPr id="33" name="Rectangle 32"/>
+              <a:t>api-gateway</a:t>
+            </a:r>
+          </a:p>
+        </p:txBody>
+      </p:sp>
+      <p:sp>
+        <p:nvSpPr>
+          <p:cNvPr id="21" name="TextBox 20"/>
+          <p:cNvSpPr txBox="1"/>
+          <p:nvPr/>
+        </p:nvSpPr>
+        <p:spPr>
+          <a:xfrm>
+            <a:off x="3520440" y="2350008"/>
+            <a:ext cx="1691640" cy="201168"/>
+          </a:xfrm>
+          <a:prstGeom prst="rect">
+            <a:avLst/>
+          </a:prstGeom>
+          <a:noFill/>
+        </p:spPr>
+        <p:txBody>
+          <a:bodyPr wrap="square">
+            <a:spAutoFit/>
+          </a:bodyPr>
+          <a:lstStyle/>
+          <a:p>
+            <a:pPr algn="l"/>
+            <a:r>
+              <a:rPr sz="900" b="0">
+                <a:solidFill>
+                  <a:srgbClr val="AAC4D8"/>
+                </a:solidFill>
+                <a:latin typeface="Calibri"/>
+              </a:rPr>
+              <a:t>Public ingress / load balancer</a:t>
+            </a:r>
+          </a:p>
+        </p:txBody>
+      </p:sp>
+      <p:sp>
+        <p:nvSpPr>
+          <p:cNvPr id="22" name="Rectangle 21"/>
           <p:cNvSpPr/>
           <p:nvPr/>
         </p:nvSpPr>
         <p:spPr>
           <a:xfrm>
-            <a:off x="411480" y="4645152"/>
-            <a:ext cx="8412480" cy="347472"/>
+            <a:off x="1097280" y="2743200"/>
+            <a:ext cx="1828800" cy="512064"/>
           </a:xfrm>
           <a:prstGeom prst="rect">
             <a:avLst/>
@@ -10866,14 +10653,92 @@
       </p:sp>
       <p:sp>
         <p:nvSpPr>
-          <p:cNvPr id="34" name="TextBox 33"/>
-          <p:cNvSpPr txBox="1"/>
-          <p:nvPr/>
-        </p:nvSpPr>
-        <p:spPr>
-          <a:xfrm>
-            <a:off x="521207" y="4663440"/>
-            <a:ext cx="8229600" cy="310896"/>
+          <p:cNvPr id="23" name="Rectangle 22"/>
+          <p:cNvSpPr/>
+          <p:nvPr/>
+        </p:nvSpPr>
+        <p:spPr>
+          <a:xfrm>
+            <a:off x="1097280" y="2743200"/>
+            <a:ext cx="1828800" cy="45720"/>
+          </a:xfrm>
+          <a:prstGeom prst="rect">
+            <a:avLst/>
+          </a:prstGeom>
+          <a:solidFill>
+            <a:srgbClr val="00BCEB"/>
+          </a:solidFill>
+          <a:ln>
+            <a:noFill/>
+          </a:ln>
+        </p:spPr>
+        <p:style>
+          <a:lnRef idx="1">
+            <a:schemeClr val="accent1"/>
+          </a:lnRef>
+          <a:fillRef idx="3">
+            <a:schemeClr val="accent1"/>
+          </a:fillRef>
+          <a:effectRef idx="2">
+            <a:schemeClr val="accent1"/>
+          </a:effectRef>
+          <a:fontRef idx="minor">
+            <a:schemeClr val="lt1"/>
+          </a:fontRef>
+        </p:style>
+        <p:txBody>
+          <a:bodyPr rtlCol="0" anchor="ctr"/>
+          <a:lstStyle/>
+          <a:p>
+            <a:pPr algn="ctr"/>
+          </a:p>
+        </p:txBody>
+      </p:sp>
+      <p:sp>
+        <p:nvSpPr>
+          <p:cNvPr id="24" name="TextBox 23"/>
+          <p:cNvSpPr txBox="1"/>
+          <p:nvPr/>
+        </p:nvSpPr>
+        <p:spPr>
+          <a:xfrm>
+            <a:off x="1188720" y="2807208"/>
+            <a:ext cx="1691640" cy="256032"/>
+          </a:xfrm>
+          <a:prstGeom prst="rect">
+            <a:avLst/>
+          </a:prstGeom>
+          <a:noFill/>
+        </p:spPr>
+        <p:txBody>
+          <a:bodyPr wrap="square">
+            <a:spAutoFit/>
+          </a:bodyPr>
+          <a:lstStyle/>
+          <a:p>
+            <a:pPr algn="l"/>
+            <a:r>
+              <a:rPr sz="1100" b="1">
+                <a:solidFill>
+                  <a:srgbClr val="FFFFFF"/>
+                </a:solidFill>
+                <a:latin typeface="Calibri"/>
+              </a:rPr>
+              <a:t>customers-service</a:t>
+            </a:r>
+          </a:p>
+        </p:txBody>
+      </p:sp>
+      <p:sp>
+        <p:nvSpPr>
+          <p:cNvPr id="25" name="TextBox 24"/>
+          <p:cNvSpPr txBox="1"/>
+          <p:nvPr/>
+        </p:nvSpPr>
+        <p:spPr>
+          <a:xfrm>
+            <a:off x="1188720" y="3035808"/>
+            <a:ext cx="1691640" cy="201168"/>
           </a:xfrm>
           <a:prstGeom prst="rect">
             <a:avLst/>
@@ -10890,18 +10755,739 @@
             <a:r>
               <a:rPr sz="900" b="0">
                 <a:solidFill>
-                  <a:srgbClr val="FFCC44"/>
-                </a:solidFill>
-                <a:latin typeface="Calibri"/>
-              </a:rPr>
-              <a:t>⚠  Demo note: detections write to alerts.log + Splunk custom events.  Production target: full Splunk UI surfacing + PagerDuty / Slack notifications.</a:t>
-            </a:r>
-          </a:p>
-        </p:txBody>
-      </p:sp>
-      <p:sp>
-        <p:nvSpPr>
-          <p:cNvPr id="35" name="TextBox 34"/>
+                  <a:srgbClr val="AAC4D8"/>
+                </a:solidFill>
+                <a:latin typeface="Calibri"/>
+              </a:rPr>
+              <a:t>Owner + pet profiles</a:t>
+            </a:r>
+          </a:p>
+        </p:txBody>
+      </p:sp>
+      <p:sp>
+        <p:nvSpPr>
+          <p:cNvPr id="26" name="Rectangle 25"/>
+          <p:cNvSpPr/>
+          <p:nvPr/>
+        </p:nvSpPr>
+        <p:spPr>
+          <a:xfrm>
+            <a:off x="3429000" y="2743200"/>
+            <a:ext cx="1828800" cy="512064"/>
+          </a:xfrm>
+          <a:prstGeom prst="rect">
+            <a:avLst/>
+          </a:prstGeom>
+          <a:solidFill>
+            <a:srgbClr val="1A3A5C"/>
+          </a:solidFill>
+          <a:ln>
+            <a:noFill/>
+          </a:ln>
+        </p:spPr>
+        <p:style>
+          <a:lnRef idx="1">
+            <a:schemeClr val="accent1"/>
+          </a:lnRef>
+          <a:fillRef idx="3">
+            <a:schemeClr val="accent1"/>
+          </a:fillRef>
+          <a:effectRef idx="2">
+            <a:schemeClr val="accent1"/>
+          </a:effectRef>
+          <a:fontRef idx="minor">
+            <a:schemeClr val="lt1"/>
+          </a:fontRef>
+        </p:style>
+        <p:txBody>
+          <a:bodyPr rtlCol="0" anchor="ctr"/>
+          <a:lstStyle/>
+          <a:p>
+            <a:pPr algn="ctr"/>
+          </a:p>
+        </p:txBody>
+      </p:sp>
+      <p:sp>
+        <p:nvSpPr>
+          <p:cNvPr id="27" name="Rectangle 26"/>
+          <p:cNvSpPr/>
+          <p:nvPr/>
+        </p:nvSpPr>
+        <p:spPr>
+          <a:xfrm>
+            <a:off x="3429000" y="2743200"/>
+            <a:ext cx="1828800" cy="45720"/>
+          </a:xfrm>
+          <a:prstGeom prst="rect">
+            <a:avLst/>
+          </a:prstGeom>
+          <a:solidFill>
+            <a:srgbClr val="00BCEB"/>
+          </a:solidFill>
+          <a:ln>
+            <a:noFill/>
+          </a:ln>
+        </p:spPr>
+        <p:style>
+          <a:lnRef idx="1">
+            <a:schemeClr val="accent1"/>
+          </a:lnRef>
+          <a:fillRef idx="3">
+            <a:schemeClr val="accent1"/>
+          </a:fillRef>
+          <a:effectRef idx="2">
+            <a:schemeClr val="accent1"/>
+          </a:effectRef>
+          <a:fontRef idx="minor">
+            <a:schemeClr val="lt1"/>
+          </a:fontRef>
+        </p:style>
+        <p:txBody>
+          <a:bodyPr rtlCol="0" anchor="ctr"/>
+          <a:lstStyle/>
+          <a:p>
+            <a:pPr algn="ctr"/>
+          </a:p>
+        </p:txBody>
+      </p:sp>
+      <p:sp>
+        <p:nvSpPr>
+          <p:cNvPr id="28" name="TextBox 27"/>
+          <p:cNvSpPr txBox="1"/>
+          <p:nvPr/>
+        </p:nvSpPr>
+        <p:spPr>
+          <a:xfrm>
+            <a:off x="3520440" y="2807208"/>
+            <a:ext cx="1691640" cy="256032"/>
+          </a:xfrm>
+          <a:prstGeom prst="rect">
+            <a:avLst/>
+          </a:prstGeom>
+          <a:noFill/>
+        </p:spPr>
+        <p:txBody>
+          <a:bodyPr wrap="square">
+            <a:spAutoFit/>
+          </a:bodyPr>
+          <a:lstStyle/>
+          <a:p>
+            <a:pPr algn="l"/>
+            <a:r>
+              <a:rPr sz="1100" b="1">
+                <a:solidFill>
+                  <a:srgbClr val="FFFFFF"/>
+                </a:solidFill>
+                <a:latin typeface="Calibri"/>
+              </a:rPr>
+              <a:t>vets-service</a:t>
+            </a:r>
+          </a:p>
+        </p:txBody>
+      </p:sp>
+      <p:sp>
+        <p:nvSpPr>
+          <p:cNvPr id="29" name="TextBox 28"/>
+          <p:cNvSpPr txBox="1"/>
+          <p:nvPr/>
+        </p:nvSpPr>
+        <p:spPr>
+          <a:xfrm>
+            <a:off x="3520440" y="3035808"/>
+            <a:ext cx="1691640" cy="201168"/>
+          </a:xfrm>
+          <a:prstGeom prst="rect">
+            <a:avLst/>
+          </a:prstGeom>
+          <a:noFill/>
+        </p:spPr>
+        <p:txBody>
+          <a:bodyPr wrap="square">
+            <a:spAutoFit/>
+          </a:bodyPr>
+          <a:lstStyle/>
+          <a:p>
+            <a:pPr algn="l"/>
+            <a:r>
+              <a:rPr sz="900" b="0">
+                <a:solidFill>
+                  <a:srgbClr val="AAC4D8"/>
+                </a:solidFill>
+                <a:latin typeface="Calibri"/>
+              </a:rPr>
+              <a:t>Veterinarian catalog</a:t>
+            </a:r>
+          </a:p>
+        </p:txBody>
+      </p:sp>
+      <p:sp>
+        <p:nvSpPr>
+          <p:cNvPr id="30" name="Rectangle 29"/>
+          <p:cNvSpPr/>
+          <p:nvPr/>
+        </p:nvSpPr>
+        <p:spPr>
+          <a:xfrm>
+            <a:off x="5760720" y="2743200"/>
+            <a:ext cx="1828800" cy="512064"/>
+          </a:xfrm>
+          <a:prstGeom prst="rect">
+            <a:avLst/>
+          </a:prstGeom>
+          <a:solidFill>
+            <a:srgbClr val="1A3A5C"/>
+          </a:solidFill>
+          <a:ln>
+            <a:noFill/>
+          </a:ln>
+        </p:spPr>
+        <p:style>
+          <a:lnRef idx="1">
+            <a:schemeClr val="accent1"/>
+          </a:lnRef>
+          <a:fillRef idx="3">
+            <a:schemeClr val="accent1"/>
+          </a:fillRef>
+          <a:effectRef idx="2">
+            <a:schemeClr val="accent1"/>
+          </a:effectRef>
+          <a:fontRef idx="minor">
+            <a:schemeClr val="lt1"/>
+          </a:fontRef>
+        </p:style>
+        <p:txBody>
+          <a:bodyPr rtlCol="0" anchor="ctr"/>
+          <a:lstStyle/>
+          <a:p>
+            <a:pPr algn="ctr"/>
+          </a:p>
+        </p:txBody>
+      </p:sp>
+      <p:sp>
+        <p:nvSpPr>
+          <p:cNvPr id="31" name="Rectangle 30"/>
+          <p:cNvSpPr/>
+          <p:nvPr/>
+        </p:nvSpPr>
+        <p:spPr>
+          <a:xfrm>
+            <a:off x="5760720" y="2743200"/>
+            <a:ext cx="1828800" cy="45720"/>
+          </a:xfrm>
+          <a:prstGeom prst="rect">
+            <a:avLst/>
+          </a:prstGeom>
+          <a:solidFill>
+            <a:srgbClr val="00BCEB"/>
+          </a:solidFill>
+          <a:ln>
+            <a:noFill/>
+          </a:ln>
+        </p:spPr>
+        <p:style>
+          <a:lnRef idx="1">
+            <a:schemeClr val="accent1"/>
+          </a:lnRef>
+          <a:fillRef idx="3">
+            <a:schemeClr val="accent1"/>
+          </a:fillRef>
+          <a:effectRef idx="2">
+            <a:schemeClr val="accent1"/>
+          </a:effectRef>
+          <a:fontRef idx="minor">
+            <a:schemeClr val="lt1"/>
+          </a:fontRef>
+        </p:style>
+        <p:txBody>
+          <a:bodyPr rtlCol="0" anchor="ctr"/>
+          <a:lstStyle/>
+          <a:p>
+            <a:pPr algn="ctr"/>
+          </a:p>
+        </p:txBody>
+      </p:sp>
+      <p:sp>
+        <p:nvSpPr>
+          <p:cNvPr id="32" name="TextBox 31"/>
+          <p:cNvSpPr txBox="1"/>
+          <p:nvPr/>
+        </p:nvSpPr>
+        <p:spPr>
+          <a:xfrm>
+            <a:off x="5852160" y="2807208"/>
+            <a:ext cx="1691640" cy="256032"/>
+          </a:xfrm>
+          <a:prstGeom prst="rect">
+            <a:avLst/>
+          </a:prstGeom>
+          <a:noFill/>
+        </p:spPr>
+        <p:txBody>
+          <a:bodyPr wrap="square">
+            <a:spAutoFit/>
+          </a:bodyPr>
+          <a:lstStyle/>
+          <a:p>
+            <a:pPr algn="l"/>
+            <a:r>
+              <a:rPr sz="1100" b="1">
+                <a:solidFill>
+                  <a:srgbClr val="FFFFFF"/>
+                </a:solidFill>
+                <a:latin typeface="Calibri"/>
+              </a:rPr>
+              <a:t>visits-service</a:t>
+            </a:r>
+          </a:p>
+        </p:txBody>
+      </p:sp>
+      <p:sp>
+        <p:nvSpPr>
+          <p:cNvPr id="33" name="TextBox 32"/>
+          <p:cNvSpPr txBox="1"/>
+          <p:nvPr/>
+        </p:nvSpPr>
+        <p:spPr>
+          <a:xfrm>
+            <a:off x="5852160" y="3035808"/>
+            <a:ext cx="1691640" cy="201168"/>
+          </a:xfrm>
+          <a:prstGeom prst="rect">
+            <a:avLst/>
+          </a:prstGeom>
+          <a:noFill/>
+        </p:spPr>
+        <p:txBody>
+          <a:bodyPr wrap="square">
+            <a:spAutoFit/>
+          </a:bodyPr>
+          <a:lstStyle/>
+          <a:p>
+            <a:pPr algn="l"/>
+            <a:r>
+              <a:rPr sz="900" b="0">
+                <a:solidFill>
+                  <a:srgbClr val="AAC4D8"/>
+                </a:solidFill>
+                <a:latin typeface="Calibri"/>
+              </a:rPr>
+              <a:t>Appointment records</a:t>
+            </a:r>
+          </a:p>
+        </p:txBody>
+      </p:sp>
+      <p:sp>
+        <p:nvSpPr>
+          <p:cNvPr id="34" name="Rectangle 33"/>
+          <p:cNvSpPr/>
+          <p:nvPr/>
+        </p:nvSpPr>
+        <p:spPr>
+          <a:xfrm>
+            <a:off x="3429000" y="3429000"/>
+            <a:ext cx="1828800" cy="512064"/>
+          </a:xfrm>
+          <a:prstGeom prst="rect">
+            <a:avLst/>
+          </a:prstGeom>
+          <a:solidFill>
+            <a:srgbClr val="5C2A1A"/>
+          </a:solidFill>
+          <a:ln>
+            <a:noFill/>
+          </a:ln>
+        </p:spPr>
+        <p:style>
+          <a:lnRef idx="1">
+            <a:schemeClr val="accent1"/>
+          </a:lnRef>
+          <a:fillRef idx="3">
+            <a:schemeClr val="accent1"/>
+          </a:fillRef>
+          <a:effectRef idx="2">
+            <a:schemeClr val="accent1"/>
+          </a:effectRef>
+          <a:fontRef idx="minor">
+            <a:schemeClr val="lt1"/>
+          </a:fontRef>
+        </p:style>
+        <p:txBody>
+          <a:bodyPr rtlCol="0" anchor="ctr"/>
+          <a:lstStyle/>
+          <a:p>
+            <a:pPr algn="ctr"/>
+          </a:p>
+        </p:txBody>
+      </p:sp>
+      <p:sp>
+        <p:nvSpPr>
+          <p:cNvPr id="35" name="Rectangle 34"/>
+          <p:cNvSpPr/>
+          <p:nvPr/>
+        </p:nvSpPr>
+        <p:spPr>
+          <a:xfrm>
+            <a:off x="3429000" y="3429000"/>
+            <a:ext cx="1828800" cy="45720"/>
+          </a:xfrm>
+          <a:prstGeom prst="rect">
+            <a:avLst/>
+          </a:prstGeom>
+          <a:solidFill>
+            <a:srgbClr val="FF6622"/>
+          </a:solidFill>
+          <a:ln>
+            <a:noFill/>
+          </a:ln>
+        </p:spPr>
+        <p:style>
+          <a:lnRef idx="1">
+            <a:schemeClr val="accent1"/>
+          </a:lnRef>
+          <a:fillRef idx="3">
+            <a:schemeClr val="accent1"/>
+          </a:fillRef>
+          <a:effectRef idx="2">
+            <a:schemeClr val="accent1"/>
+          </a:effectRef>
+          <a:fontRef idx="minor">
+            <a:schemeClr val="lt1"/>
+          </a:fontRef>
+        </p:style>
+        <p:txBody>
+          <a:bodyPr rtlCol="0" anchor="ctr"/>
+          <a:lstStyle/>
+          <a:p>
+            <a:pPr algn="ctr"/>
+          </a:p>
+        </p:txBody>
+      </p:sp>
+      <p:sp>
+        <p:nvSpPr>
+          <p:cNvPr id="36" name="TextBox 35"/>
+          <p:cNvSpPr txBox="1"/>
+          <p:nvPr/>
+        </p:nvSpPr>
+        <p:spPr>
+          <a:xfrm>
+            <a:off x="3520440" y="3493008"/>
+            <a:ext cx="1691640" cy="256032"/>
+          </a:xfrm>
+          <a:prstGeom prst="rect">
+            <a:avLst/>
+          </a:prstGeom>
+          <a:noFill/>
+        </p:spPr>
+        <p:txBody>
+          <a:bodyPr wrap="square">
+            <a:spAutoFit/>
+          </a:bodyPr>
+          <a:lstStyle/>
+          <a:p>
+            <a:pPr algn="l"/>
+            <a:r>
+              <a:rPr sz="1100" b="1">
+                <a:solidFill>
+                  <a:srgbClr val="FFFFFF"/>
+                </a:solidFill>
+                <a:latin typeface="Calibri"/>
+              </a:rPr>
+              <a:t>petclinic-db</a:t>
+            </a:r>
+          </a:p>
+        </p:txBody>
+      </p:sp>
+      <p:sp>
+        <p:nvSpPr>
+          <p:cNvPr id="37" name="TextBox 36"/>
+          <p:cNvSpPr txBox="1"/>
+          <p:nvPr/>
+        </p:nvSpPr>
+        <p:spPr>
+          <a:xfrm>
+            <a:off x="3520440" y="3721608"/>
+            <a:ext cx="1691640" cy="201168"/>
+          </a:xfrm>
+          <a:prstGeom prst="rect">
+            <a:avLst/>
+          </a:prstGeom>
+          <a:noFill/>
+        </p:spPr>
+        <p:txBody>
+          <a:bodyPr wrap="square">
+            <a:spAutoFit/>
+          </a:bodyPr>
+          <a:lstStyle/>
+          <a:p>
+            <a:pPr algn="l"/>
+            <a:r>
+              <a:rPr sz="900" b="0">
+                <a:solidFill>
+                  <a:srgbClr val="AAC4D8"/>
+                </a:solidFill>
+                <a:latin typeface="Calibri"/>
+              </a:rPr>
+              <a:t>MySQL (shared data store)</a:t>
+            </a:r>
+          </a:p>
+        </p:txBody>
+      </p:sp>
+      <p:sp>
+        <p:nvSpPr>
+          <p:cNvPr id="38" name="TextBox 37"/>
+          <p:cNvSpPr txBox="1"/>
+          <p:nvPr/>
+        </p:nvSpPr>
+        <p:spPr>
+          <a:xfrm>
+            <a:off x="4343400" y="1901952"/>
+            <a:ext cx="182880" cy="228600"/>
+          </a:xfrm>
+          <a:prstGeom prst="rect">
+            <a:avLst/>
+          </a:prstGeom>
+          <a:noFill/>
+        </p:spPr>
+        <p:txBody>
+          <a:bodyPr wrap="square">
+            <a:spAutoFit/>
+          </a:bodyPr>
+          <a:lstStyle/>
+          <a:p>
+            <a:pPr algn="l"/>
+            <a:r>
+              <a:rPr sz="900" b="0">
+                <a:solidFill>
+                  <a:srgbClr val="6699BB"/>
+                </a:solidFill>
+                <a:latin typeface="Calibri"/>
+              </a:rPr>
+              <a:t>▼</a:t>
+            </a:r>
+          </a:p>
+        </p:txBody>
+      </p:sp>
+      <p:sp>
+        <p:nvSpPr>
+          <p:cNvPr id="39" name="TextBox 38"/>
+          <p:cNvSpPr txBox="1"/>
+          <p:nvPr/>
+        </p:nvSpPr>
+        <p:spPr>
+          <a:xfrm>
+            <a:off x="4343400" y="2587752"/>
+            <a:ext cx="182880" cy="228600"/>
+          </a:xfrm>
+          <a:prstGeom prst="rect">
+            <a:avLst/>
+          </a:prstGeom>
+          <a:noFill/>
+        </p:spPr>
+        <p:txBody>
+          <a:bodyPr wrap="square">
+            <a:spAutoFit/>
+          </a:bodyPr>
+          <a:lstStyle/>
+          <a:p>
+            <a:pPr algn="l"/>
+            <a:r>
+              <a:rPr sz="900" b="0">
+                <a:solidFill>
+                  <a:srgbClr val="6699BB"/>
+                </a:solidFill>
+                <a:latin typeface="Calibri"/>
+              </a:rPr>
+              <a:t>▼</a:t>
+            </a:r>
+          </a:p>
+        </p:txBody>
+      </p:sp>
+      <p:sp>
+        <p:nvSpPr>
+          <p:cNvPr id="40" name="TextBox 39"/>
+          <p:cNvSpPr txBox="1"/>
+          <p:nvPr/>
+        </p:nvSpPr>
+        <p:spPr>
+          <a:xfrm>
+            <a:off x="1965960" y="3273552"/>
+            <a:ext cx="182880" cy="228600"/>
+          </a:xfrm>
+          <a:prstGeom prst="rect">
+            <a:avLst/>
+          </a:prstGeom>
+          <a:noFill/>
+        </p:spPr>
+        <p:txBody>
+          <a:bodyPr wrap="square">
+            <a:spAutoFit/>
+          </a:bodyPr>
+          <a:lstStyle/>
+          <a:p>
+            <a:pPr algn="l"/>
+            <a:r>
+              <a:rPr sz="900" b="0">
+                <a:solidFill>
+                  <a:srgbClr val="6699BB"/>
+                </a:solidFill>
+                <a:latin typeface="Calibri"/>
+              </a:rPr>
+              <a:t>▼</a:t>
+            </a:r>
+          </a:p>
+        </p:txBody>
+      </p:sp>
+      <p:sp>
+        <p:nvSpPr>
+          <p:cNvPr id="41" name="TextBox 40"/>
+          <p:cNvSpPr txBox="1"/>
+          <p:nvPr/>
+        </p:nvSpPr>
+        <p:spPr>
+          <a:xfrm>
+            <a:off x="4343400" y="3273552"/>
+            <a:ext cx="182880" cy="228600"/>
+          </a:xfrm>
+          <a:prstGeom prst="rect">
+            <a:avLst/>
+          </a:prstGeom>
+          <a:noFill/>
+        </p:spPr>
+        <p:txBody>
+          <a:bodyPr wrap="square">
+            <a:spAutoFit/>
+          </a:bodyPr>
+          <a:lstStyle/>
+          <a:p>
+            <a:pPr algn="l"/>
+            <a:r>
+              <a:rPr sz="900" b="0">
+                <a:solidFill>
+                  <a:srgbClr val="6699BB"/>
+                </a:solidFill>
+                <a:latin typeface="Calibri"/>
+              </a:rPr>
+              <a:t>▼</a:t>
+            </a:r>
+          </a:p>
+        </p:txBody>
+      </p:sp>
+      <p:sp>
+        <p:nvSpPr>
+          <p:cNvPr id="42" name="TextBox 41"/>
+          <p:cNvSpPr txBox="1"/>
+          <p:nvPr/>
+        </p:nvSpPr>
+        <p:spPr>
+          <a:xfrm>
+            <a:off x="6629400" y="3273552"/>
+            <a:ext cx="182880" cy="228600"/>
+          </a:xfrm>
+          <a:prstGeom prst="rect">
+            <a:avLst/>
+          </a:prstGeom>
+          <a:noFill/>
+        </p:spPr>
+        <p:txBody>
+          <a:bodyPr wrap="square">
+            <a:spAutoFit/>
+          </a:bodyPr>
+          <a:lstStyle/>
+          <a:p>
+            <a:pPr algn="l"/>
+            <a:r>
+              <a:rPr sz="900" b="0">
+                <a:solidFill>
+                  <a:srgbClr val="6699BB"/>
+                </a:solidFill>
+                <a:latin typeface="Calibri"/>
+              </a:rPr>
+              <a:t>▼</a:t>
+            </a:r>
+          </a:p>
+        </p:txBody>
+      </p:sp>
+      <p:sp>
+        <p:nvSpPr>
+          <p:cNvPr id="43" name="Rectangle 42"/>
+          <p:cNvSpPr/>
+          <p:nvPr/>
+        </p:nvSpPr>
+        <p:spPr>
+          <a:xfrm>
+            <a:off x="411480" y="4407408"/>
+            <a:ext cx="8412480" cy="384048"/>
+          </a:xfrm>
+          <a:prstGeom prst="rect">
+            <a:avLst/>
+          </a:prstGeom>
+          <a:solidFill>
+            <a:srgbClr val="1A3A5C"/>
+          </a:solidFill>
+          <a:ln>
+            <a:noFill/>
+          </a:ln>
+        </p:spPr>
+        <p:style>
+          <a:lnRef idx="1">
+            <a:schemeClr val="accent1"/>
+          </a:lnRef>
+          <a:fillRef idx="3">
+            <a:schemeClr val="accent1"/>
+          </a:fillRef>
+          <a:effectRef idx="2">
+            <a:schemeClr val="accent1"/>
+          </a:effectRef>
+          <a:fontRef idx="minor">
+            <a:schemeClr val="lt1"/>
+          </a:fontRef>
+        </p:style>
+        <p:txBody>
+          <a:bodyPr rtlCol="0" anchor="ctr"/>
+          <a:lstStyle/>
+          <a:p>
+            <a:pPr algn="ctr"/>
+          </a:p>
+        </p:txBody>
+      </p:sp>
+      <p:sp>
+        <p:nvSpPr>
+          <p:cNvPr id="44" name="TextBox 43"/>
+          <p:cNvSpPr txBox="1"/>
+          <p:nvPr/>
+        </p:nvSpPr>
+        <p:spPr>
+          <a:xfrm>
+            <a:off x="521207" y="4425696"/>
+            <a:ext cx="8229600" cy="347472"/>
+          </a:xfrm>
+          <a:prstGeom prst="rect">
+            <a:avLst/>
+          </a:prstGeom>
+          <a:noFill/>
+        </p:spPr>
+        <p:txBody>
+          <a:bodyPr wrap="square">
+            <a:spAutoFit/>
+          </a:bodyPr>
+          <a:lstStyle/>
+          <a:p>
+            <a:pPr algn="l"/>
+            <a:r>
+              <a:rPr sz="1000" b="0">
+                <a:solidFill>
+                  <a:srgbClr val="BBCCDD"/>
+                </a:solidFill>
+                <a:latin typeface="Calibri"/>
+              </a:rPr>
+              <a:t>Loadgen hits api-gateway every ~5 s  ·  OTel Java agent on all services  ·  Traces + metrics flow to Splunk Observability (env: petclinicmbtest)</a:t>
+            </a:r>
+          </a:p>
+        </p:txBody>
+      </p:sp>
+      <p:sp>
+        <p:nvSpPr>
+          <p:cNvPr id="45" name="TextBox 44"/>
           <p:cNvSpPr txBox="1"/>
           <p:nvPr/>
         </p:nvSpPr>
@@ -10969,7 +11555,7 @@
         <p:spPr>
           <a:xfrm>
             <a:off x="0" y="0"/>
-            <a:ext cx="320040" cy="5148072"/>
+            <a:ext cx="164592" cy="5148072"/>
           </a:xfrm>
           <a:prstGeom prst="rect">
             <a:avLst/>
@@ -11011,36 +11597,1169 @@
         </p:nvSpPr>
         <p:spPr>
           <a:xfrm>
-            <a:off x="548640" y="1645920"/>
-            <a:ext cx="7772400" cy="1097280"/>
-          </a:xfrm>
-          <a:prstGeom prst="rect">
-            <a:avLst/>
-          </a:prstGeom>
-          <a:noFill/>
-        </p:spPr>
-        <p:txBody>
-          <a:bodyPr wrap="square">
-            <a:spAutoFit/>
-          </a:bodyPr>
-          <a:lstStyle/>
-          <a:p>
-            <a:pPr algn="l"/>
-            <a:r>
-              <a:rPr sz="5400" b="1">
+            <a:off x="411480" y="228600"/>
+            <a:ext cx="8229600" cy="502920"/>
+          </a:xfrm>
+          <a:prstGeom prst="rect">
+            <a:avLst/>
+          </a:prstGeom>
+          <a:noFill/>
+        </p:spPr>
+        <p:txBody>
+          <a:bodyPr wrap="square">
+            <a:spAutoFit/>
+          </a:bodyPr>
+          <a:lstStyle/>
+          <a:p>
+            <a:pPr algn="l"/>
+            <a:r>
+              <a:rPr sz="2600" b="1">
                 <a:solidFill>
                   <a:srgbClr val="00BCEB"/>
                 </a:solidFill>
                 <a:latin typeface="Calibri"/>
               </a:rPr>
-              <a:t>Live Demo</a:t>
-            </a:r>
-          </a:p>
-        </p:txBody>
-      </p:sp>
-      <p:sp>
-        <p:nvSpPr>
-          <p:cNvPr id="4" name="TextBox 3"/>
+              <a:t>What We'll Demo Today</a:t>
+            </a:r>
+          </a:p>
+        </p:txBody>
+      </p:sp>
+      <p:sp>
+        <p:nvSpPr>
+          <p:cNvPr id="4" name="Rectangle 3"/>
+          <p:cNvSpPr/>
+          <p:nvPr/>
+        </p:nvSpPr>
+        <p:spPr>
+          <a:xfrm>
+            <a:off x="411480" y="804672"/>
+            <a:ext cx="8412480" cy="36576"/>
+          </a:xfrm>
+          <a:prstGeom prst="rect">
+            <a:avLst/>
+          </a:prstGeom>
+          <a:solidFill>
+            <a:srgbClr val="00BCEB"/>
+          </a:solidFill>
+          <a:ln>
+            <a:noFill/>
+          </a:ln>
+        </p:spPr>
+        <p:style>
+          <a:lnRef idx="1">
+            <a:schemeClr val="accent1"/>
+          </a:lnRef>
+          <a:fillRef idx="3">
+            <a:schemeClr val="accent1"/>
+          </a:fillRef>
+          <a:effectRef idx="2">
+            <a:schemeClr val="accent1"/>
+          </a:effectRef>
+          <a:fontRef idx="minor">
+            <a:schemeClr val="lt1"/>
+          </a:fontRef>
+        </p:style>
+        <p:txBody>
+          <a:bodyPr rtlCol="0" anchor="ctr"/>
+          <a:lstStyle/>
+          <a:p>
+            <a:pPr algn="ctr"/>
+          </a:p>
+        </p:txBody>
+      </p:sp>
+      <p:sp>
+        <p:nvSpPr>
+          <p:cNvPr id="5" name="Rectangle 4"/>
+          <p:cNvSpPr/>
+          <p:nvPr/>
+        </p:nvSpPr>
+        <p:spPr>
+          <a:xfrm>
+            <a:off x="411480" y="969264"/>
+            <a:ext cx="8412480" cy="461772"/>
+          </a:xfrm>
+          <a:prstGeom prst="rect">
+            <a:avLst/>
+          </a:prstGeom>
+          <a:solidFill>
+            <a:srgbClr val="334E68"/>
+          </a:solidFill>
+          <a:ln>
+            <a:noFill/>
+          </a:ln>
+        </p:spPr>
+        <p:style>
+          <a:lnRef idx="1">
+            <a:schemeClr val="accent1"/>
+          </a:lnRef>
+          <a:fillRef idx="3">
+            <a:schemeClr val="accent1"/>
+          </a:fillRef>
+          <a:effectRef idx="2">
+            <a:schemeClr val="accent1"/>
+          </a:effectRef>
+          <a:fontRef idx="minor">
+            <a:schemeClr val="lt1"/>
+          </a:fontRef>
+        </p:style>
+        <p:txBody>
+          <a:bodyPr rtlCol="0" anchor="ctr"/>
+          <a:lstStyle/>
+          <a:p>
+            <a:pPr algn="ctr"/>
+          </a:p>
+        </p:txBody>
+      </p:sp>
+      <p:sp>
+        <p:nvSpPr>
+          <p:cNvPr id="6" name="TextBox 5"/>
+          <p:cNvSpPr txBox="1"/>
+          <p:nvPr/>
+        </p:nvSpPr>
+        <p:spPr>
+          <a:xfrm>
+            <a:off x="484632" y="1014984"/>
+            <a:ext cx="914400" cy="384048"/>
+          </a:xfrm>
+          <a:prstGeom prst="rect">
+            <a:avLst/>
+          </a:prstGeom>
+          <a:noFill/>
+        </p:spPr>
+        <p:txBody>
+          <a:bodyPr wrap="square">
+            <a:spAutoFit/>
+          </a:bodyPr>
+          <a:lstStyle/>
+          <a:p>
+            <a:pPr algn="l"/>
+            <a:r>
+              <a:rPr sz="1100" b="1">
+                <a:solidFill>
+                  <a:srgbClr val="00BCEB"/>
+                </a:solidFill>
+                <a:latin typeface="Calibri"/>
+              </a:rPr>
+              <a:t>Demo 0</a:t>
+            </a:r>
+          </a:p>
+        </p:txBody>
+      </p:sp>
+      <p:sp>
+        <p:nvSpPr>
+          <p:cNvPr id="7" name="TextBox 6"/>
+          <p:cNvSpPr txBox="1"/>
+          <p:nvPr/>
+        </p:nvSpPr>
+        <p:spPr>
+          <a:xfrm>
+            <a:off x="1463040" y="1014984"/>
+            <a:ext cx="1371600" cy="384048"/>
+          </a:xfrm>
+          <a:prstGeom prst="rect">
+            <a:avLst/>
+          </a:prstGeom>
+          <a:noFill/>
+        </p:spPr>
+        <p:txBody>
+          <a:bodyPr wrap="square">
+            <a:spAutoFit/>
+          </a:bodyPr>
+          <a:lstStyle/>
+          <a:p>
+            <a:pPr algn="l"/>
+            <a:r>
+              <a:rPr sz="1100" b="1">
+                <a:solidFill>
+                  <a:srgbClr val="FFFFFF"/>
+                </a:solidFill>
+                <a:latin typeface="Calibri"/>
+              </a:rPr>
+              <a:t>Steady State</a:t>
+            </a:r>
+          </a:p>
+        </p:txBody>
+      </p:sp>
+      <p:sp>
+        <p:nvSpPr>
+          <p:cNvPr id="8" name="TextBox 7"/>
+          <p:cNvSpPr txBox="1"/>
+          <p:nvPr/>
+        </p:nvSpPr>
+        <p:spPr>
+          <a:xfrm>
+            <a:off x="2926080" y="1014984"/>
+            <a:ext cx="5806440" cy="411480"/>
+          </a:xfrm>
+          <a:prstGeom prst="rect">
+            <a:avLst/>
+          </a:prstGeom>
+          <a:noFill/>
+        </p:spPr>
+        <p:txBody>
+          <a:bodyPr wrap="square">
+            <a:spAutoFit/>
+          </a:bodyPr>
+          <a:lstStyle/>
+          <a:p>
+            <a:pPr algn="l"/>
+            <a:r>
+              <a:rPr sz="1000" b="0">
+                <a:solidFill>
+                  <a:srgbClr val="BBCCDD"/>
+                </a:solidFill>
+                <a:latin typeface="Calibri"/>
+              </a:rPr>
+              <a:t>Framework in normal operation — baselines learned, cron running, zero anomalies</a:t>
+            </a:r>
+          </a:p>
+        </p:txBody>
+      </p:sp>
+      <p:sp>
+        <p:nvSpPr>
+          <p:cNvPr id="9" name="TextBox 8"/>
+          <p:cNvSpPr txBox="1"/>
+          <p:nvPr/>
+        </p:nvSpPr>
+        <p:spPr>
+          <a:xfrm>
+            <a:off x="484632" y="1504188"/>
+            <a:ext cx="914400" cy="384048"/>
+          </a:xfrm>
+          <a:prstGeom prst="rect">
+            <a:avLst/>
+          </a:prstGeom>
+          <a:noFill/>
+        </p:spPr>
+        <p:txBody>
+          <a:bodyPr wrap="square">
+            <a:spAutoFit/>
+          </a:bodyPr>
+          <a:lstStyle/>
+          <a:p>
+            <a:pPr algn="l"/>
+            <a:r>
+              <a:rPr sz="1100" b="1">
+                <a:solidFill>
+                  <a:srgbClr val="00BCEB"/>
+                </a:solidFill>
+                <a:latin typeface="Calibri"/>
+              </a:rPr>
+              <a:t>Demo 1</a:t>
+            </a:r>
+          </a:p>
+        </p:txBody>
+      </p:sp>
+      <p:sp>
+        <p:nvSpPr>
+          <p:cNvPr id="10" name="TextBox 9"/>
+          <p:cNvSpPr txBox="1"/>
+          <p:nvPr/>
+        </p:nvSpPr>
+        <p:spPr>
+          <a:xfrm>
+            <a:off x="1463040" y="1504188"/>
+            <a:ext cx="1371600" cy="384048"/>
+          </a:xfrm>
+          <a:prstGeom prst="rect">
+            <a:avLst/>
+          </a:prstGeom>
+          <a:noFill/>
+        </p:spPr>
+        <p:txBody>
+          <a:bodyPr wrap="square">
+            <a:spAutoFit/>
+          </a:bodyPr>
+          <a:lstStyle/>
+          <a:p>
+            <a:pPr algn="l"/>
+            <a:r>
+              <a:rPr sz="1100" b="1">
+                <a:solidFill>
+                  <a:srgbClr val="FFFFFF"/>
+                </a:solidFill>
+                <a:latin typeface="Calibri"/>
+              </a:rPr>
+              <a:t>DB Outage → New Error Signatures</a:t>
+            </a:r>
+          </a:p>
+        </p:txBody>
+      </p:sp>
+      <p:sp>
+        <p:nvSpPr>
+          <p:cNvPr id="11" name="TextBox 10"/>
+          <p:cNvSpPr txBox="1"/>
+          <p:nvPr/>
+        </p:nvSpPr>
+        <p:spPr>
+          <a:xfrm>
+            <a:off x="2926080" y="1504188"/>
+            <a:ext cx="5806440" cy="411480"/>
+          </a:xfrm>
+          <a:prstGeom prst="rect">
+            <a:avLst/>
+          </a:prstGeom>
+          <a:noFill/>
+        </p:spPr>
+        <p:txBody>
+          <a:bodyPr wrap="square">
+            <a:spAutoFit/>
+          </a:bodyPr>
+          <a:lstStyle/>
+          <a:p>
+            <a:pPr algn="l"/>
+            <a:r>
+              <a:rPr sz="1000" b="0">
+                <a:solidFill>
+                  <a:srgbClr val="BBCCDD"/>
+                </a:solidFill>
+                <a:latin typeface="Calibri"/>
+              </a:rPr>
+              <a:t>Database goes down. New CannotCreateTransactionException fires on first occurrence. Claude: INCIDENT, PAGE_ONCALL</a:t>
+            </a:r>
+          </a:p>
+        </p:txBody>
+      </p:sp>
+      <p:sp>
+        <p:nvSpPr>
+          <p:cNvPr id="12" name="Rectangle 11"/>
+          <p:cNvSpPr/>
+          <p:nvPr/>
+        </p:nvSpPr>
+        <p:spPr>
+          <a:xfrm>
+            <a:off x="411480" y="1947672"/>
+            <a:ext cx="8412480" cy="461772"/>
+          </a:xfrm>
+          <a:prstGeom prst="rect">
+            <a:avLst/>
+          </a:prstGeom>
+          <a:solidFill>
+            <a:srgbClr val="334E68"/>
+          </a:solidFill>
+          <a:ln>
+            <a:noFill/>
+          </a:ln>
+        </p:spPr>
+        <p:style>
+          <a:lnRef idx="1">
+            <a:schemeClr val="accent1"/>
+          </a:lnRef>
+          <a:fillRef idx="3">
+            <a:schemeClr val="accent1"/>
+          </a:fillRef>
+          <a:effectRef idx="2">
+            <a:schemeClr val="accent1"/>
+          </a:effectRef>
+          <a:fontRef idx="minor">
+            <a:schemeClr val="lt1"/>
+          </a:fontRef>
+        </p:style>
+        <p:txBody>
+          <a:bodyPr rtlCol="0" anchor="ctr"/>
+          <a:lstStyle/>
+          <a:p>
+            <a:pPr algn="ctr"/>
+          </a:p>
+        </p:txBody>
+      </p:sp>
+      <p:sp>
+        <p:nvSpPr>
+          <p:cNvPr id="13" name="TextBox 12"/>
+          <p:cNvSpPr txBox="1"/>
+          <p:nvPr/>
+        </p:nvSpPr>
+        <p:spPr>
+          <a:xfrm>
+            <a:off x="484632" y="1993392"/>
+            <a:ext cx="914400" cy="384048"/>
+          </a:xfrm>
+          <a:prstGeom prst="rect">
+            <a:avLst/>
+          </a:prstGeom>
+          <a:noFill/>
+        </p:spPr>
+        <p:txBody>
+          <a:bodyPr wrap="square">
+            <a:spAutoFit/>
+          </a:bodyPr>
+          <a:lstStyle/>
+          <a:p>
+            <a:pPr algn="l"/>
+            <a:r>
+              <a:rPr sz="1100" b="1">
+                <a:solidFill>
+                  <a:srgbClr val="00BCEB"/>
+                </a:solidFill>
+                <a:latin typeface="Calibri"/>
+              </a:rPr>
+              <a:t>Demo 2</a:t>
+            </a:r>
+          </a:p>
+        </p:txBody>
+      </p:sp>
+      <p:sp>
+        <p:nvSpPr>
+          <p:cNvPr id="14" name="TextBox 13"/>
+          <p:cNvSpPr txBox="1"/>
+          <p:nvPr/>
+        </p:nvSpPr>
+        <p:spPr>
+          <a:xfrm>
+            <a:off x="1463040" y="1993392"/>
+            <a:ext cx="1371600" cy="384048"/>
+          </a:xfrm>
+          <a:prstGeom prst="rect">
+            <a:avLst/>
+          </a:prstGeom>
+          <a:noFill/>
+        </p:spPr>
+        <p:txBody>
+          <a:bodyPr wrap="square">
+            <a:spAutoFit/>
+          </a:bodyPr>
+          <a:lstStyle/>
+          <a:p>
+            <a:pPr algn="l"/>
+            <a:r>
+              <a:rPr sz="1100" b="1">
+                <a:solidFill>
+                  <a:srgbClr val="FFFFFF"/>
+                </a:solidFill>
+                <a:latin typeface="Calibri"/>
+              </a:rPr>
+              <a:t>Bad Deploy → First-Occurrence Error</a:t>
+            </a:r>
+          </a:p>
+        </p:txBody>
+      </p:sp>
+      <p:sp>
+        <p:nvSpPr>
+          <p:cNvPr id="15" name="TextBox 14"/>
+          <p:cNvSpPr txBox="1"/>
+          <p:nvPr/>
+        </p:nvSpPr>
+        <p:spPr>
+          <a:xfrm>
+            <a:off x="2926080" y="1993392"/>
+            <a:ext cx="5806440" cy="411480"/>
+          </a:xfrm>
+          <a:prstGeom prst="rect">
+            <a:avLst/>
+          </a:prstGeom>
+          <a:noFill/>
+        </p:spPr>
+        <p:txBody>
+          <a:bodyPr wrap="square">
+            <a:spAutoFit/>
+          </a:bodyPr>
+          <a:lstStyle/>
+          <a:p>
+            <a:pPr algn="l"/>
+            <a:r>
+              <a:rPr sz="1000" b="0">
+                <a:solidFill>
+                  <a:srgbClr val="BBCCDD"/>
+                </a:solidFill>
+                <a:latin typeface="Calibri"/>
+              </a:rPr>
+              <a:t>visits-service crashes on startup. First request to the dead service triggers detection. No threshold exceeded</a:t>
+            </a:r>
+          </a:p>
+        </p:txBody>
+      </p:sp>
+      <p:sp>
+        <p:nvSpPr>
+          <p:cNvPr id="16" name="TextBox 15"/>
+          <p:cNvSpPr txBox="1"/>
+          <p:nvPr/>
+        </p:nvSpPr>
+        <p:spPr>
+          <a:xfrm>
+            <a:off x="484632" y="2482596"/>
+            <a:ext cx="914400" cy="384048"/>
+          </a:xfrm>
+          <a:prstGeom prst="rect">
+            <a:avLst/>
+          </a:prstGeom>
+          <a:noFill/>
+        </p:spPr>
+        <p:txBody>
+          <a:bodyPr wrap="square">
+            <a:spAutoFit/>
+          </a:bodyPr>
+          <a:lstStyle/>
+          <a:p>
+            <a:pPr algn="l"/>
+            <a:r>
+              <a:rPr sz="1100" b="1">
+                <a:solidFill>
+                  <a:srgbClr val="00BCEB"/>
+                </a:solidFill>
+                <a:latin typeface="Calibri"/>
+              </a:rPr>
+              <a:t>Demo 3</a:t>
+            </a:r>
+          </a:p>
+        </p:txBody>
+      </p:sp>
+      <p:sp>
+        <p:nvSpPr>
+          <p:cNvPr id="17" name="TextBox 16"/>
+          <p:cNvSpPr txBox="1"/>
+          <p:nvPr/>
+        </p:nvSpPr>
+        <p:spPr>
+          <a:xfrm>
+            <a:off x="1463040" y="2482596"/>
+            <a:ext cx="1371600" cy="384048"/>
+          </a:xfrm>
+          <a:prstGeom prst="rect">
+            <a:avLst/>
+          </a:prstGeom>
+          <a:noFill/>
+        </p:spPr>
+        <p:txBody>
+          <a:bodyPr wrap="square">
+            <a:spAutoFit/>
+          </a:bodyPr>
+          <a:lstStyle/>
+          <a:p>
+            <a:pPr algn="l"/>
+            <a:r>
+              <a:rPr sz="1100" b="1">
+                <a:solidFill>
+                  <a:srgbClr val="FFFFFF"/>
+                </a:solidFill>
+                <a:latin typeface="Calibri"/>
+              </a:rPr>
+              <a:t>Missing Service → AI Triage</a:t>
+            </a:r>
+          </a:p>
+        </p:txBody>
+      </p:sp>
+      <p:sp>
+        <p:nvSpPr>
+          <p:cNvPr id="18" name="TextBox 17"/>
+          <p:cNvSpPr txBox="1"/>
+          <p:nvPr/>
+        </p:nvSpPr>
+        <p:spPr>
+          <a:xfrm>
+            <a:off x="2926080" y="2482596"/>
+            <a:ext cx="5806440" cy="411480"/>
+          </a:xfrm>
+          <a:prstGeom prst="rect">
+            <a:avLst/>
+          </a:prstGeom>
+          <a:noFill/>
+        </p:spPr>
+        <p:txBody>
+          <a:bodyPr wrap="square">
+            <a:spAutoFit/>
+          </a:bodyPr>
+          <a:lstStyle/>
+          <a:p>
+            <a:pPr algn="l"/>
+            <a:r>
+              <a:rPr sz="1000" b="0">
+                <a:solidFill>
+                  <a:srgbClr val="BBCCDD"/>
+                </a:solidFill>
+                <a:latin typeface="Calibri"/>
+              </a:rPr>
+              <a:t>vets-service killed. Framework detects structural absence from traces. Claude produces root cause + action in 3 min</a:t>
+            </a:r>
+          </a:p>
+        </p:txBody>
+      </p:sp>
+      <p:sp>
+        <p:nvSpPr>
+          <p:cNvPr id="19" name="Rectangle 18"/>
+          <p:cNvSpPr/>
+          <p:nvPr/>
+        </p:nvSpPr>
+        <p:spPr>
+          <a:xfrm>
+            <a:off x="411480" y="2926080"/>
+            <a:ext cx="8412480" cy="461772"/>
+          </a:xfrm>
+          <a:prstGeom prst="rect">
+            <a:avLst/>
+          </a:prstGeom>
+          <a:solidFill>
+            <a:srgbClr val="334E68"/>
+          </a:solidFill>
+          <a:ln>
+            <a:noFill/>
+          </a:ln>
+        </p:spPr>
+        <p:style>
+          <a:lnRef idx="1">
+            <a:schemeClr val="accent1"/>
+          </a:lnRef>
+          <a:fillRef idx="3">
+            <a:schemeClr val="accent1"/>
+          </a:fillRef>
+          <a:effectRef idx="2">
+            <a:schemeClr val="accent1"/>
+          </a:effectRef>
+          <a:fontRef idx="minor">
+            <a:schemeClr val="lt1"/>
+          </a:fontRef>
+        </p:style>
+        <p:txBody>
+          <a:bodyPr rtlCol="0" anchor="ctr"/>
+          <a:lstStyle/>
+          <a:p>
+            <a:pPr algn="ctr"/>
+          </a:p>
+        </p:txBody>
+      </p:sp>
+      <p:sp>
+        <p:nvSpPr>
+          <p:cNvPr id="20" name="TextBox 19"/>
+          <p:cNvSpPr txBox="1"/>
+          <p:nvPr/>
+        </p:nvSpPr>
+        <p:spPr>
+          <a:xfrm>
+            <a:off x="484632" y="2971800"/>
+            <a:ext cx="914400" cy="384048"/>
+          </a:xfrm>
+          <a:prstGeom prst="rect">
+            <a:avLst/>
+          </a:prstGeom>
+          <a:noFill/>
+        </p:spPr>
+        <p:txBody>
+          <a:bodyPr wrap="square">
+            <a:spAutoFit/>
+          </a:bodyPr>
+          <a:lstStyle/>
+          <a:p>
+            <a:pPr algn="l"/>
+            <a:r>
+              <a:rPr sz="1100" b="1">
+                <a:solidFill>
+                  <a:srgbClr val="00BCEB"/>
+                </a:solidFill>
+                <a:latin typeface="Calibri"/>
+              </a:rPr>
+              <a:t>Demo 4</a:t>
+            </a:r>
+          </a:p>
+        </p:txBody>
+      </p:sp>
+      <p:sp>
+        <p:nvSpPr>
+          <p:cNvPr id="21" name="TextBox 20"/>
+          <p:cNvSpPr txBox="1"/>
+          <p:nvPr/>
+        </p:nvSpPr>
+        <p:spPr>
+          <a:xfrm>
+            <a:off x="1463040" y="2971800"/>
+            <a:ext cx="1371600" cy="384048"/>
+          </a:xfrm>
+          <a:prstGeom prst="rect">
+            <a:avLst/>
+          </a:prstGeom>
+          <a:noFill/>
+        </p:spPr>
+        <p:txBody>
+          <a:bodyPr wrap="square">
+            <a:spAutoFit/>
+          </a:bodyPr>
+          <a:lstStyle/>
+          <a:p>
+            <a:pPr algn="l"/>
+            <a:r>
+              <a:rPr sz="1100" b="1">
+                <a:solidFill>
+                  <a:srgbClr val="FFFFFF"/>
+                </a:solidFill>
+                <a:latin typeface="Calibri"/>
+              </a:rPr>
+              <a:t>All-Tier Correlation</a:t>
+            </a:r>
+          </a:p>
+        </p:txBody>
+      </p:sp>
+      <p:sp>
+        <p:nvSpPr>
+          <p:cNvPr id="22" name="TextBox 21"/>
+          <p:cNvSpPr txBox="1"/>
+          <p:nvPr/>
+        </p:nvSpPr>
+        <p:spPr>
+          <a:xfrm>
+            <a:off x="2926080" y="2971800"/>
+            <a:ext cx="5806440" cy="411480"/>
+          </a:xfrm>
+          <a:prstGeom prst="rect">
+            <a:avLst/>
+          </a:prstGeom>
+          <a:noFill/>
+        </p:spPr>
+        <p:txBody>
+          <a:bodyPr wrap="square">
+            <a:spAutoFit/>
+          </a:bodyPr>
+          <a:lstStyle/>
+          <a:p>
+            <a:pPr algn="l"/>
+            <a:r>
+              <a:rPr sz="1000" b="0">
+                <a:solidFill>
+                  <a:srgbClr val="BBCCDD"/>
+                </a:solidFill>
+                <a:latin typeface="Calibri"/>
+              </a:rPr>
+              <a:t>Both vets-service and DB down simultaneously. AutoDetect + trace drift + error signatures → [Critical] MULTI_TIER</a:t>
+            </a:r>
+          </a:p>
+        </p:txBody>
+      </p:sp>
+      <p:sp>
+        <p:nvSpPr>
+          <p:cNvPr id="23" name="TextBox 22"/>
+          <p:cNvSpPr txBox="1"/>
+          <p:nvPr/>
+        </p:nvSpPr>
+        <p:spPr>
+          <a:xfrm>
+            <a:off x="484632" y="3461004"/>
+            <a:ext cx="914400" cy="384048"/>
+          </a:xfrm>
+          <a:prstGeom prst="rect">
+            <a:avLst/>
+          </a:prstGeom>
+          <a:noFill/>
+        </p:spPr>
+        <p:txBody>
+          <a:bodyPr wrap="square">
+            <a:spAutoFit/>
+          </a:bodyPr>
+          <a:lstStyle/>
+          <a:p>
+            <a:pPr algn="l"/>
+            <a:r>
+              <a:rPr sz="1100" b="1">
+                <a:solidFill>
+                  <a:srgbClr val="00BCEB"/>
+                </a:solidFill>
+                <a:latin typeface="Calibri"/>
+              </a:rPr>
+              <a:t>Demo 5</a:t>
+            </a:r>
+          </a:p>
+        </p:txBody>
+      </p:sp>
+      <p:sp>
+        <p:nvSpPr>
+          <p:cNvPr id="24" name="TextBox 23"/>
+          <p:cNvSpPr txBox="1"/>
+          <p:nvPr/>
+        </p:nvSpPr>
+        <p:spPr>
+          <a:xfrm>
+            <a:off x="1463040" y="3461004"/>
+            <a:ext cx="1371600" cy="384048"/>
+          </a:xfrm>
+          <a:prstGeom prst="rect">
+            <a:avLst/>
+          </a:prstGeom>
+          <a:noFill/>
+        </p:spPr>
+        <p:txBody>
+          <a:bodyPr wrap="square">
+            <a:spAutoFit/>
+          </a:bodyPr>
+          <a:lstStyle/>
+          <a:p>
+            <a:pPr algn="l"/>
+            <a:r>
+              <a:rPr sz="1100" b="1">
+                <a:solidFill>
+                  <a:srgbClr val="FFFFFF"/>
+                </a:solidFill>
+                <a:latin typeface="Calibri"/>
+              </a:rPr>
+              <a:t>Deploy-Correlated Severity Downgrade</a:t>
+            </a:r>
+          </a:p>
+        </p:txBody>
+      </p:sp>
+      <p:sp>
+        <p:nvSpPr>
+          <p:cNvPr id="25" name="TextBox 24"/>
+          <p:cNvSpPr txBox="1"/>
+          <p:nvPr/>
+        </p:nvSpPr>
+        <p:spPr>
+          <a:xfrm>
+            <a:off x="2926080" y="3461004"/>
+            <a:ext cx="5806440" cy="411480"/>
+          </a:xfrm>
+          <a:prstGeom prst="rect">
+            <a:avLst/>
+          </a:prstGeom>
+          <a:noFill/>
+        </p:spPr>
+        <p:txBody>
+          <a:bodyPr wrap="square">
+            <a:spAutoFit/>
+          </a:bodyPr>
+          <a:lstStyle/>
+          <a:p>
+            <a:pPr algn="l"/>
+            <a:r>
+              <a:rPr sz="1000" b="0">
+                <a:solidFill>
+                  <a:srgbClr val="BBCCDD"/>
+                </a:solidFill>
+                <a:latin typeface="Calibri"/>
+              </a:rPr>
+              <a:t>Bad deploy announced via CI/CD hook. correlate.py finds the deployment event and downgrades Major → Minor</a:t>
+            </a:r>
+          </a:p>
+        </p:txBody>
+      </p:sp>
+      <p:sp>
+        <p:nvSpPr>
+          <p:cNvPr id="26" name="Rectangle 25"/>
+          <p:cNvSpPr/>
+          <p:nvPr/>
+        </p:nvSpPr>
+        <p:spPr>
+          <a:xfrm>
+            <a:off x="411480" y="3904488"/>
+            <a:ext cx="8412480" cy="461772"/>
+          </a:xfrm>
+          <a:prstGeom prst="rect">
+            <a:avLst/>
+          </a:prstGeom>
+          <a:solidFill>
+            <a:srgbClr val="334E68"/>
+          </a:solidFill>
+          <a:ln>
+            <a:noFill/>
+          </a:ln>
+        </p:spPr>
+        <p:style>
+          <a:lnRef idx="1">
+            <a:schemeClr val="accent1"/>
+          </a:lnRef>
+          <a:fillRef idx="3">
+            <a:schemeClr val="accent1"/>
+          </a:fillRef>
+          <a:effectRef idx="2">
+            <a:schemeClr val="accent1"/>
+          </a:effectRef>
+          <a:fontRef idx="minor">
+            <a:schemeClr val="lt1"/>
+          </a:fontRef>
+        </p:style>
+        <p:txBody>
+          <a:bodyPr rtlCol="0" anchor="ctr"/>
+          <a:lstStyle/>
+          <a:p>
+            <a:pPr algn="ctr"/>
+          </a:p>
+        </p:txBody>
+      </p:sp>
+      <p:sp>
+        <p:nvSpPr>
+          <p:cNvPr id="27" name="TextBox 26"/>
+          <p:cNvSpPr txBox="1"/>
+          <p:nvPr/>
+        </p:nvSpPr>
+        <p:spPr>
+          <a:xfrm>
+            <a:off x="484632" y="3950208"/>
+            <a:ext cx="914400" cy="384048"/>
+          </a:xfrm>
+          <a:prstGeom prst="rect">
+            <a:avLst/>
+          </a:prstGeom>
+          <a:noFill/>
+        </p:spPr>
+        <p:txBody>
+          <a:bodyPr wrap="square">
+            <a:spAutoFit/>
+          </a:bodyPr>
+          <a:lstStyle/>
+          <a:p>
+            <a:pPr algn="l"/>
+            <a:r>
+              <a:rPr sz="1100" b="1">
+                <a:solidFill>
+                  <a:srgbClr val="00BCEB"/>
+                </a:solidFill>
+                <a:latin typeface="Calibri"/>
+              </a:rPr>
+              <a:t>Demo 6</a:t>
+            </a:r>
+          </a:p>
+        </p:txBody>
+      </p:sp>
+      <p:sp>
+        <p:nvSpPr>
+          <p:cNvPr id="28" name="TextBox 27"/>
+          <p:cNvSpPr txBox="1"/>
+          <p:nvPr/>
+        </p:nvSpPr>
+        <p:spPr>
+          <a:xfrm>
+            <a:off x="1463040" y="3950208"/>
+            <a:ext cx="1371600" cy="384048"/>
+          </a:xfrm>
+          <a:prstGeom prst="rect">
+            <a:avLst/>
+          </a:prstGeom>
+          <a:noFill/>
+        </p:spPr>
+        <p:txBody>
+          <a:bodyPr wrap="square">
+            <a:spAutoFit/>
+          </a:bodyPr>
+          <a:lstStyle/>
+          <a:p>
+            <a:pPr algn="l"/>
+            <a:r>
+              <a:rPr sz="1100" b="1">
+                <a:solidFill>
+                  <a:srgbClr val="FFFFFF"/>
+                </a:solidFill>
+                <a:latin typeface="Calibri"/>
+              </a:rPr>
+              <a:t>Self-Healing</a:t>
+            </a:r>
+          </a:p>
+        </p:txBody>
+      </p:sp>
+      <p:sp>
+        <p:nvSpPr>
+          <p:cNvPr id="29" name="TextBox 28"/>
+          <p:cNvSpPr txBox="1"/>
+          <p:nvPr/>
+        </p:nvSpPr>
+        <p:spPr>
+          <a:xfrm>
+            <a:off x="2926080" y="3950208"/>
+            <a:ext cx="5806440" cy="411480"/>
+          </a:xfrm>
+          <a:prstGeom prst="rect">
+            <a:avLst/>
+          </a:prstGeom>
+          <a:noFill/>
+        </p:spPr>
+        <p:txBody>
+          <a:bodyPr wrap="square">
+            <a:spAutoFit/>
+          </a:bodyPr>
+          <a:lstStyle/>
+          <a:p>
+            <a:pPr algn="l"/>
+            <a:r>
+              <a:rPr sz="1000" b="0">
+                <a:solidFill>
+                  <a:srgbClr val="BBCCDD"/>
+                </a:solidFill>
+                <a:latin typeface="Calibri"/>
+              </a:rPr>
+              <a:t>New call path auto-promoted after 2 clean watch runs. Baseline healer scores windows and re-learns autonomously</a:t>
+            </a:r>
+          </a:p>
+        </p:txBody>
+      </p:sp>
+      <p:sp>
+        <p:nvSpPr>
+          <p:cNvPr id="30" name="TextBox 29"/>
+          <p:cNvSpPr txBox="1"/>
+          <p:nvPr/>
+        </p:nvSpPr>
+        <p:spPr>
+          <a:xfrm>
+            <a:off x="484632" y="4439412"/>
+            <a:ext cx="914400" cy="384048"/>
+          </a:xfrm>
+          <a:prstGeom prst="rect">
+            <a:avLst/>
+          </a:prstGeom>
+          <a:noFill/>
+        </p:spPr>
+        <p:txBody>
+          <a:bodyPr wrap="square">
+            <a:spAutoFit/>
+          </a:bodyPr>
+          <a:lstStyle/>
+          <a:p>
+            <a:pPr algn="l"/>
+            <a:r>
+              <a:rPr sz="1100" b="1">
+                <a:solidFill>
+                  <a:srgbClr val="00BCEB"/>
+                </a:solidFill>
+                <a:latin typeface="Calibri"/>
+              </a:rPr>
+              <a:t>Demo 7</a:t>
+            </a:r>
+          </a:p>
+        </p:txBody>
+      </p:sp>
+      <p:sp>
+        <p:nvSpPr>
+          <p:cNvPr id="31" name="TextBox 30"/>
+          <p:cNvSpPr txBox="1"/>
+          <p:nvPr/>
+        </p:nvSpPr>
+        <p:spPr>
+          <a:xfrm>
+            <a:off x="1463040" y="4439412"/>
+            <a:ext cx="1371600" cy="384048"/>
+          </a:xfrm>
+          <a:prstGeom prst="rect">
+            <a:avLst/>
+          </a:prstGeom>
+          <a:noFill/>
+        </p:spPr>
+        <p:txBody>
+          <a:bodyPr wrap="square">
+            <a:spAutoFit/>
+          </a:bodyPr>
+          <a:lstStyle/>
+          <a:p>
+            <a:pPr algn="l"/>
+            <a:r>
+              <a:rPr sz="1100" b="1">
+                <a:solidFill>
+                  <a:srgbClr val="FFFFFF"/>
+                </a:solidFill>
+                <a:latin typeface="Calibri"/>
+              </a:rPr>
+              <a:t>Auto-Onboarding</a:t>
+            </a:r>
+          </a:p>
+        </p:txBody>
+      </p:sp>
+      <p:sp>
+        <p:nvSpPr>
+          <p:cNvPr id="32" name="TextBox 31"/>
+          <p:cNvSpPr txBox="1"/>
+          <p:nvPr/>
+        </p:nvSpPr>
+        <p:spPr>
+          <a:xfrm>
+            <a:off x="2926080" y="4439412"/>
+            <a:ext cx="5806440" cy="411480"/>
+          </a:xfrm>
+          <a:prstGeom prst="rect">
+            <a:avLst/>
+          </a:prstGeom>
+          <a:noFill/>
+        </p:spPr>
+        <p:txBody>
+          <a:bodyPr wrap="square">
+            <a:spAutoFit/>
+          </a:bodyPr>
+          <a:lstStyle/>
+          <a:p>
+            <a:pPr algn="l"/>
+            <a:r>
+              <a:rPr sz="1000" b="0">
+                <a:solidFill>
+                  <a:srgbClr val="BBCCDD"/>
+                </a:solidFill>
+                <a:latin typeface="Calibri"/>
+              </a:rPr>
+              <a:t>New environment discovered. Baselines built, dashboard created, cron scheduled, runbook generated — in 60 seconds</a:t>
+            </a:r>
+          </a:p>
+        </p:txBody>
+      </p:sp>
+      <p:sp>
+        <p:nvSpPr>
+          <p:cNvPr id="33" name="Rectangle 32"/>
+          <p:cNvSpPr/>
+          <p:nvPr/>
+        </p:nvSpPr>
+        <p:spPr>
+          <a:xfrm>
+            <a:off x="411480" y="4645152"/>
+            <a:ext cx="8412480" cy="347472"/>
+          </a:xfrm>
+          <a:prstGeom prst="rect">
+            <a:avLst/>
+          </a:prstGeom>
+          <a:solidFill>
+            <a:srgbClr val="1A3A5C"/>
+          </a:solidFill>
+          <a:ln>
+            <a:noFill/>
+          </a:ln>
+        </p:spPr>
+        <p:style>
+          <a:lnRef idx="1">
+            <a:schemeClr val="accent1"/>
+          </a:lnRef>
+          <a:fillRef idx="3">
+            <a:schemeClr val="accent1"/>
+          </a:fillRef>
+          <a:effectRef idx="2">
+            <a:schemeClr val="accent1"/>
+          </a:effectRef>
+          <a:fontRef idx="minor">
+            <a:schemeClr val="lt1"/>
+          </a:fontRef>
+        </p:style>
+        <p:txBody>
+          <a:bodyPr rtlCol="0" anchor="ctr"/>
+          <a:lstStyle/>
+          <a:p>
+            <a:pPr algn="ctr"/>
+          </a:p>
+        </p:txBody>
+      </p:sp>
+      <p:sp>
+        <p:nvSpPr>
+          <p:cNvPr id="34" name="TextBox 33"/>
+          <p:cNvSpPr txBox="1"/>
+          <p:nvPr/>
+        </p:nvSpPr>
+        <p:spPr>
+          <a:xfrm>
+            <a:off x="521207" y="4663440"/>
+            <a:ext cx="8229600" cy="310896"/>
+          </a:xfrm>
+          <a:prstGeom prst="rect">
+            <a:avLst/>
+          </a:prstGeom>
+          <a:noFill/>
+        </p:spPr>
+        <p:txBody>
+          <a:bodyPr wrap="square">
+            <a:spAutoFit/>
+          </a:bodyPr>
+          <a:lstStyle/>
+          <a:p>
+            <a:pPr algn="l"/>
+            <a:r>
+              <a:rPr sz="900" b="0">
+                <a:solidFill>
+                  <a:srgbClr val="FFCC44"/>
+                </a:solidFill>
+                <a:latin typeface="Calibri"/>
+              </a:rPr>
+              <a:t>⚠  Demo note: detections write to alerts.log + Splunk custom events.  Production target: full Splunk UI surfacing + PagerDuty / Slack notifications.</a:t>
+            </a:r>
+          </a:p>
+        </p:txBody>
+      </p:sp>
+      <p:sp>
+        <p:nvSpPr>
+          <p:cNvPr id="35" name="TextBox 34"/>
           <p:cNvSpPr txBox="1"/>
           <p:nvPr/>
         </p:nvSpPr>

</xml_diff>

<commit_message>
Replace PagerDuty references with Splunk On-Call
Co-Authored-By: Claude Opus 4.6 <noreply@anthropic.com>
</commit_message>
<xml_diff>
--- a/Behavioral_Baseline_Deck.pptx
+++ b/Behavioral_Baseline_Deck.pptx
@@ -3843,7 +3843,7 @@
 APM onboarding — a toggle, not a script.
   •  Detections surface alongside AutoDetect
        alerts in the Splunk UI
-  •  Same notification routing (PagerDuty,
+  •  Same notification routing (Splunk On-Call,
        Slack, webhook)
   •  Same muting, SLO wiring, and RBAC
   •  No external scripts or cron jobs</a:t>
@@ -12752,7 +12752,7 @@
                 </a:solidFill>
                 <a:latin typeface="Calibri"/>
               </a:rPr>
-              <a:t>⚠  Demo note: detections write to alerts.log + Splunk custom events.  Production target: full Splunk UI surfacing + PagerDuty / Slack notifications.</a:t>
+              <a:t>⚠  Demo note: detections write to alerts.log + Splunk custom events.  Production target: full Splunk UI surfacing + Splunk On-Call / Slack notifications.</a:t>
             </a:r>
           </a:p>
         </p:txBody>

</xml_diff>